<commit_message>
Figures and tables from paper_out_20261007_112616 (server run with the p1-matched counts)
Counts and per-query cost tables identical to the local check; scorecard carries the re-timed runs.

Co-Authored-By: Claude Opus 5.5 <noreply@anthropic.com>
Claude-Session: https://claude.ai/code/session_01RE6mmwrje1bnZRkuzuQPCF
</commit_message>
<xml_diff>
--- a/presentation/PercEF_review.pptx
+++ b/presentation/PercEF_review.pptx
@@ -122,36 +122,36 @@
   <p:extLst>
     <p:ext uri="{521415D9-36F7-43E2-AB2F-B90AF26B5E84}">
       <p14:sectionLst xmlns:p14="http://schemas.microsoft.com/office/powerpoint/2010/main">
-        <p14:section name="Introduction" id="{72b00142-40ce-bcc6-af35-200d261edc09}">
+        <p14:section name="Introduction" id="{81c2fd61-5d50-79b7-a46e-81168758b339}">
           <p14:sldIdLst>
             <p14:sldId id="256"/>
             <p14:sldId id="257"/>
           </p14:sldIdLst>
         </p14:section>
-        <p14:section name="Problem statement" id="{10c852b3-1494-e012-6276-6dc138596769}">
+        <p14:section name="Problem statement" id="{988665ba-8b1f-880a-faa3-47f08a546cdf}">
           <p14:sldIdLst>
             <p14:sldId id="258"/>
           </p14:sldIdLst>
         </p14:section>
-        <p14:section name="Existing methodology" id="{6ea89dfb-227a-88cb-7d65-84567898fe5d}">
+        <p14:section name="Existing methodology" id="{93049634-5bef-34e9-c149-830aa7a56e58}">
           <p14:sldIdLst>
             <p14:sldId id="259"/>
             <p14:sldId id="260"/>
           </p14:sldIdLst>
         </p14:section>
-        <p14:section name="Our method" id="{c08458c1-ca02-5635-a888-5c600a64f70d}">
+        <p14:section name="Our method" id="{4ff71ba2-8873-7c4a-9a9a-df0a8df772a7}">
           <p14:sldIdLst>
             <p14:sldId id="261"/>
             <p14:sldId id="262"/>
             <p14:sldId id="263"/>
           </p14:sldIdLst>
         </p14:section>
-        <p14:section name="Novelty" id="{6e68807e-6f77-d244-97fe-588f2cbe0995}">
+        <p14:section name="Novelty" id="{481929f3-0eea-d124-8109-da4fcb41b362}">
           <p14:sldIdLst>
             <p14:sldId id="264"/>
           </p14:sldIdLst>
         </p14:section>
-        <p14:section name="Results" id="{3bcf318a-368f-db38-aa9b-376bf41a317a}">
+        <p14:section name="Results" id="{a2fcd2e8-91c0-fede-e967-37b717023d5c}">
           <p14:sldIdLst>
             <p14:sldId id="265"/>
             <p14:sldId id="266"/>
@@ -160,7 +160,7 @@
             <p14:sldId id="269"/>
           </p14:sldIdLst>
         </p14:section>
-        <p14:section name="Wrap-up" id="{4f80a16b-5314-3227-8a89-1c58332df2cb}">
+        <p14:section name="Wrap-up" id="{3c1638ac-c8f2-f208-c353-4cf03ecc2c02}">
           <p14:sldIdLst>
             <p14:sldId id="270"/>
             <p14:sldId id="271"/>
@@ -16254,7 +16254,7 @@
       </p:sp>
       <p:pic>
         <p:nvPicPr>
-          <p:cNvPr id="3" name="KS survey figure" descr="E:\shenvipranav\projects\hybridAdaEf\server_results\paper_out_20261006_203218\fig1_ks_survey.png">    </p:cNvPr>
+          <p:cNvPr id="3" name="KS survey figure" descr="E:\shenvipranav\projects\hybridAdaEf\server_results\paper_out_20261007_112616\fig1_ks_survey.png">    </p:cNvPr>
           <p:cNvPicPr>
             <a:picLocks noChangeAspect="1"/>
           </p:cNvPicPr>

</xml_diff>

<commit_message>
Slide 11: say how ranking is measured; 13 / 16 and 1 / 16 as separate counts
Co-Authored-By: Claude Opus 5.5 <noreply@anthropic.com>
Claude-Session: https://claude.ai/code/session_01RE6mmwrje1bnZRkuzuQPCF
</commit_message>
<xml_diff>
--- a/presentation/PercEF_review.pptx
+++ b/presentation/PercEF_review.pptx
@@ -4,6 +4,9 @@
   <p:sldMasterIdLst>
     <p:sldMasterId id="2147483648" r:id="rId1"/>
   </p:sldMasterIdLst>
+  <p:notesMasterIdLst>
+    <p:notesMasterId r:id="rId18"/>
+  </p:notesMasterIdLst>
   <p:sldIdLst>
     <p:sldId id="256" r:id="rId2"/>
     <p:sldId id="257" r:id="rId3"/>
@@ -22,9 +25,6 @@
     <p:sldId id="270" r:id="rId16"/>
     <p:sldId id="271" r:id="rId17"/>
   </p:sldIdLst>
-  <p:notesMasterIdLst>
-    <p:notesMasterId r:id="rId18"/>
-  </p:notesMasterIdLst>
   <p:sldSz cx="12192000" cy="6858000"/>
   <p:notesSz cx="6858000" cy="12192000"/>
   <p:defaultTextStyle>
@@ -122,36 +122,36 @@
   <p:extLst>
     <p:ext uri="{521415D9-36F7-43E2-AB2F-B90AF26B5E84}">
       <p14:sectionLst xmlns:p14="http://schemas.microsoft.com/office/powerpoint/2010/main">
-        <p14:section name="Introduction" id="{81c2fd61-5d50-79b7-a46e-81168758b339}">
+        <p14:section name="Introduction" id="{81C2FD61-5D50-79B7-A46E-81168758B339}">
           <p14:sldIdLst>
             <p14:sldId id="256"/>
             <p14:sldId id="257"/>
           </p14:sldIdLst>
         </p14:section>
-        <p14:section name="Problem statement" id="{988665ba-8b1f-880a-faa3-47f08a546cdf}">
+        <p14:section name="Problem statement" id="{988665BA-8B1F-880A-FAA3-47F08A546CDF}">
           <p14:sldIdLst>
             <p14:sldId id="258"/>
           </p14:sldIdLst>
         </p14:section>
-        <p14:section name="Existing methodology" id="{93049634-5bef-34e9-c149-830aa7a56e58}">
+        <p14:section name="Existing methodology" id="{93049634-5BEF-34E9-C149-830AA7A56E58}">
           <p14:sldIdLst>
             <p14:sldId id="259"/>
             <p14:sldId id="260"/>
           </p14:sldIdLst>
         </p14:section>
-        <p14:section name="Our method" id="{4ff71ba2-8873-7c4a-9a9a-df0a8df772a7}">
+        <p14:section name="Our method" id="{4FF71BA2-8873-7C4A-9A9A-DF0A8DF772A7}">
           <p14:sldIdLst>
             <p14:sldId id="261"/>
             <p14:sldId id="262"/>
             <p14:sldId id="263"/>
           </p14:sldIdLst>
         </p14:section>
-        <p14:section name="Novelty" id="{481929f3-0eea-d124-8109-da4fcb41b362}">
+        <p14:section name="Novelty" id="{481929F3-0EEA-D124-8109-DA4FCB41B362}">
           <p14:sldIdLst>
             <p14:sldId id="264"/>
           </p14:sldIdLst>
         </p14:section>
-        <p14:section name="Results" id="{a2fcd2e8-91c0-fede-e967-37b717023d5c}">
+        <p14:section name="Results" id="{A2FCD2E8-91C0-FEDE-E967-37B717023D5C}">
           <p14:sldIdLst>
             <p14:sldId id="265"/>
             <p14:sldId id="266"/>
@@ -160,7 +160,7 @@
             <p14:sldId id="269"/>
           </p14:sldIdLst>
         </p14:section>
-        <p14:section name="Wrap-up" id="{3c1638ac-c8f2-f208-c353-4cf03ecc2c02}">
+        <p14:section name="Wrap-up" id="{3C1638AC-C8F2-F208-C353-4CF03ECC2C02}">
           <p14:sldIdLst>
             <p14:sldId id="270"/>
             <p14:sldId id="271"/>
@@ -176,9 +176,11 @@
 </file>
 
 <file path=ppt/charts/chart1.xml><?xml version="1.0" encoding="utf-8"?>
-<c:chartSpace xmlns:c="http://schemas.openxmlformats.org/drawingml/2006/chart" xmlns:a="http://schemas.openxmlformats.org/drawingml/2006/main" xmlns:r="http://schemas.openxmlformats.org/officeDocument/2006/relationships">
+<c:chartSpace xmlns:c="http://schemas.openxmlformats.org/drawingml/2006/chart" xmlns:a="http://schemas.openxmlformats.org/drawingml/2006/main" xmlns:r="http://schemas.openxmlformats.org/officeDocument/2006/relationships" xmlns:c16r2="http://schemas.microsoft.com/office/drawing/2015/06/chart">
   <c:date1904 val="0"/>
+  <c:lang val="en-US"/>
   <c:roundedCorners val="1"/>
+  <c:style val="2"/>
   <c:chart>
     <c:title>
       <c:tx>
@@ -195,7 +197,7 @@
               </a:defRPr>
             </a:pPr>
             <a:r>
-              <a:rPr sz="1400" b="0" i="0" u="none" strike="noStrike">
+              <a:rPr lang="en-US" sz="1400" b="0" i="0" u="none" strike="noStrike">
                 <a:solidFill>
                   <a:srgbClr val="1F2933"/>
                 </a:solidFill>
@@ -206,7 +208,6 @@
           </a:p>
         </c:rich>
       </c:tx>
-      <c:layout/>
       <c:overlay val="0"/>
     </c:title>
     <c:autoTitleDeleted val="0"/>
@@ -239,18 +240,26 @@
           <c:invertIfNegative val="0"/>
           <c:dLbls>
             <c:numFmt formatCode="0.0" sourceLinked="0"/>
+            <c:spPr>
+              <a:noFill/>
+              <a:ln>
+                <a:noFill/>
+              </a:ln>
+              <a:effectLst/>
+            </c:spPr>
             <c:txPr>
               <a:bodyPr/>
               <a:lstStyle/>
               <a:p>
                 <a:pPr>
-                  <a:defRPr b="0" i="0" strike="noStrike" sz="1000" u="none">
+                  <a:defRPr sz="1000" b="0" i="0" u="none" strike="noStrike">
                     <a:solidFill>
                       <a:srgbClr val="1F2933"/>
                     </a:solidFill>
                     <a:latin typeface="Arial"/>
                   </a:defRPr>
                 </a:pPr>
+                <a:endParaRPr lang="en-US"/>
               </a:p>
             </c:txPr>
             <c:showLegendKey val="0"/>
@@ -260,40 +269,43 @@
             <c:showPercent val="0"/>
             <c:showBubbleSize val="0"/>
             <c:showLeaderLines val="0"/>
+            <c:extLst>
+              <c:ext xmlns:c15="http://schemas.microsoft.com/office/drawing/2012/chart" uri="{CE6537A1-D6FC-4f65-9D91-7224C49458BB}">
+                <c15:showLeaderLines val="0"/>
+              </c:ext>
+            </c:extLst>
           </c:dLbls>
           <c:cat>
-            <c:multiLvlStrRef>
+            <c:strRef>
               <c:f>Sheet1!$A$2:$A$9</c:f>
-              <c:multiLvlStrCache>
+              <c:strCache>
                 <c:ptCount val="8"/>
-                <c:lvl>
-                  <c:pt idx="0">
-                    <c:v>DeepImage</c:v>
-                  </c:pt>
-                  <c:pt idx="1">
-                    <c:v>Deep1B</c:v>
-                  </c:pt>
-                  <c:pt idx="2">
-                    <c:v>Landmark-DINO</c:v>
-                  </c:pt>
-                  <c:pt idx="3">
-                    <c:v>iNat-ResNet</c:v>
-                  </c:pt>
-                  <c:pt idx="4">
-                    <c:v>SIFT-1M</c:v>
-                  </c:pt>
-                  <c:pt idx="5">
-                    <c:v>Fashion-MNIST</c:v>
-                  </c:pt>
-                  <c:pt idx="6">
-                    <c:v>Yambda</c:v>
-                  </c:pt>
-                  <c:pt idx="7">
-                    <c:v>GIST</c:v>
-                  </c:pt>
-                </c:lvl>
-              </c:multiLvlStrCache>
-            </c:multiLvlStrRef>
+                <c:pt idx="0">
+                  <c:v>DeepImage</c:v>
+                </c:pt>
+                <c:pt idx="1">
+                  <c:v>Deep1B</c:v>
+                </c:pt>
+                <c:pt idx="2">
+                  <c:v>Landmark-DINO</c:v>
+                </c:pt>
+                <c:pt idx="3">
+                  <c:v>iNat-ResNet</c:v>
+                </c:pt>
+                <c:pt idx="4">
+                  <c:v>SIFT-1M</c:v>
+                </c:pt>
+                <c:pt idx="5">
+                  <c:v>Fashion-MNIST</c:v>
+                </c:pt>
+                <c:pt idx="6">
+                  <c:v>Yambda</c:v>
+                </c:pt>
+                <c:pt idx="7">
+                  <c:v>GIST</c:v>
+                </c:pt>
+              </c:strCache>
+            </c:strRef>
           </c:cat>
           <c:val>
             <c:numRef>
@@ -317,7 +329,7 @@
                   <c:v>2.8</c:v>
                 </c:pt>
                 <c:pt idx="5">
-                  <c:v>1.1</c:v>
+                  <c:v>1.1000000000000001</c:v>
                 </c:pt>
                 <c:pt idx="6">
                   <c:v>0.7</c:v>
@@ -328,6 +340,11 @@
               </c:numCache>
             </c:numRef>
           </c:val>
+          <c:extLst>
+            <c:ext xmlns:c16="http://schemas.microsoft.com/office/drawing/2014/chart" uri="{C3380CC4-5D6E-409C-BE32-E72D297353CC}">
+              <c16:uniqueId val="{00000000-A4A3-471C-8C4B-505DFD22CC44}"/>
+            </c:ext>
+          </c:extLst>
         </c:ser>
         <c:ser>
           <c:idx val="1"/>
@@ -352,18 +369,26 @@
           <c:invertIfNegative val="0"/>
           <c:dLbls>
             <c:numFmt formatCode="0.0" sourceLinked="0"/>
+            <c:spPr>
+              <a:noFill/>
+              <a:ln>
+                <a:noFill/>
+              </a:ln>
+              <a:effectLst/>
+            </c:spPr>
             <c:txPr>
               <a:bodyPr/>
               <a:lstStyle/>
               <a:p>
                 <a:pPr>
-                  <a:defRPr b="0" i="0" strike="noStrike" sz="1000" u="none">
+                  <a:defRPr sz="1000" b="0" i="0" u="none" strike="noStrike">
                     <a:solidFill>
                       <a:srgbClr val="1F2933"/>
                     </a:solidFill>
                     <a:latin typeface="Arial"/>
                   </a:defRPr>
                 </a:pPr>
+                <a:endParaRPr lang="en-US"/>
               </a:p>
             </c:txPr>
             <c:showLegendKey val="0"/>
@@ -373,40 +398,43 @@
             <c:showPercent val="0"/>
             <c:showBubbleSize val="0"/>
             <c:showLeaderLines val="0"/>
+            <c:extLst>
+              <c:ext xmlns:c15="http://schemas.microsoft.com/office/drawing/2012/chart" uri="{CE6537A1-D6FC-4f65-9D91-7224C49458BB}">
+                <c15:showLeaderLines val="0"/>
+              </c:ext>
+            </c:extLst>
           </c:dLbls>
           <c:cat>
-            <c:multiLvlStrRef>
+            <c:strRef>
               <c:f>Sheet1!$A$2:$A$9</c:f>
-              <c:multiLvlStrCache>
+              <c:strCache>
                 <c:ptCount val="8"/>
-                <c:lvl>
-                  <c:pt idx="0">
-                    <c:v>DeepImage</c:v>
-                  </c:pt>
-                  <c:pt idx="1">
-                    <c:v>Deep1B</c:v>
-                  </c:pt>
-                  <c:pt idx="2">
-                    <c:v>Landmark-DINO</c:v>
-                  </c:pt>
-                  <c:pt idx="3">
-                    <c:v>iNat-ResNet</c:v>
-                  </c:pt>
-                  <c:pt idx="4">
-                    <c:v>SIFT-1M</c:v>
-                  </c:pt>
-                  <c:pt idx="5">
-                    <c:v>Fashion-MNIST</c:v>
-                  </c:pt>
-                  <c:pt idx="6">
-                    <c:v>Yambda</c:v>
-                  </c:pt>
-                  <c:pt idx="7">
-                    <c:v>GIST</c:v>
-                  </c:pt>
-                </c:lvl>
-              </c:multiLvlStrCache>
-            </c:multiLvlStrRef>
+                <c:pt idx="0">
+                  <c:v>DeepImage</c:v>
+                </c:pt>
+                <c:pt idx="1">
+                  <c:v>Deep1B</c:v>
+                </c:pt>
+                <c:pt idx="2">
+                  <c:v>Landmark-DINO</c:v>
+                </c:pt>
+                <c:pt idx="3">
+                  <c:v>iNat-ResNet</c:v>
+                </c:pt>
+                <c:pt idx="4">
+                  <c:v>SIFT-1M</c:v>
+                </c:pt>
+                <c:pt idx="5">
+                  <c:v>Fashion-MNIST</c:v>
+                </c:pt>
+                <c:pt idx="6">
+                  <c:v>Yambda</c:v>
+                </c:pt>
+                <c:pt idx="7">
+                  <c:v>GIST</c:v>
+                </c:pt>
+              </c:strCache>
+            </c:strRef>
           </c:cat>
           <c:val>
             <c:numRef>
@@ -430,7 +458,7 @@
                   <c:v>0</c:v>
                 </c:pt>
                 <c:pt idx="5">
-                  <c:v>-1.1</c:v>
+                  <c:v>-1.1000000000000001</c:v>
                 </c:pt>
                 <c:pt idx="6">
                   <c:v>-0.1</c:v>
@@ -441,36 +469,23 @@
               </c:numCache>
             </c:numRef>
           </c:val>
+          <c:extLst>
+            <c:ext xmlns:c16="http://schemas.microsoft.com/office/drawing/2014/chart" uri="{C3380CC4-5D6E-409C-BE32-E72D297353CC}">
+              <c16:uniqueId val="{00000001-A4A3-471C-8C4B-505DFD22CC44}"/>
+            </c:ext>
+          </c:extLst>
         </c:ser>
         <c:dLbls>
-          <c:numFmt formatCode="0.0" sourceLinked="0"/>
-          <c:txPr>
-            <a:bodyPr/>
-            <a:lstStyle/>
-            <a:p>
-              <a:pPr>
-                <a:defRPr b="0" i="0" strike="noStrike" sz="1000" u="none">
-                  <a:solidFill>
-                    <a:srgbClr val="1F2933"/>
-                  </a:solidFill>
-                  <a:latin typeface="Arial"/>
-                </a:defRPr>
-              </a:pPr>
-            </a:p>
-          </c:txPr>
           <c:showLegendKey val="0"/>
           <c:showVal val="1"/>
           <c:showCatName val="0"/>
           <c:showSerName val="0"/>
           <c:showPercent val="0"/>
           <c:showBubbleSize val="0"/>
-          <c:showLeaderLines val="0"/>
         </c:dLbls>
         <c:gapWidth val="150"/>
-        <c:overlap val="0"/>
         <c:axId val="2094734554"/>
         <c:axId val="2094734552"/>
-        <c:axId val="2094734556"/>
       </c:barChart>
       <c:catAx>
         <c:axId val="2094734554"/>
@@ -511,6 +526,7 @@
         <c:crosses val="autoZero"/>
         <c:auto val="1"/>
         <c:lblAlgn val="ctr"/>
+        <c:lblOffset val="100"/>
         <c:noMultiLvlLbl val="1"/>
       </c:catAx>
       <c:valAx>
@@ -519,7 +535,7 @@
           <c:orientation val="minMax"/>
         </c:scaling>
         <c:delete val="0"/>
-        <c:axPos val="b"/>
+        <c:axPos val="t"/>
         <c:majorGridlines>
           <c:spPr>
             <a:ln w="9525" cap="flat">
@@ -590,6 +606,7 @@
     </c:legend>
     <c:plotVisOnly val="1"/>
     <c:dispBlanksAs val="span"/>
+    <c:showDLblsOverMax val="1"/>
   </c:chart>
   <c:spPr>
     <a:noFill/>
@@ -605,9 +622,11 @@
 </file>
 
 <file path=ppt/charts/chart2.xml><?xml version="1.0" encoding="utf-8"?>
-<c:chartSpace xmlns:c="http://schemas.openxmlformats.org/drawingml/2006/chart" xmlns:a="http://schemas.openxmlformats.org/drawingml/2006/main" xmlns:r="http://schemas.openxmlformats.org/officeDocument/2006/relationships">
+<c:chartSpace xmlns:c="http://schemas.openxmlformats.org/drawingml/2006/chart" xmlns:a="http://schemas.openxmlformats.org/drawingml/2006/main" xmlns:r="http://schemas.openxmlformats.org/officeDocument/2006/relationships" xmlns:c16r2="http://schemas.microsoft.com/office/drawing/2015/06/chart">
   <c:date1904 val="0"/>
+  <c:lang val="en-US"/>
   <c:roundedCorners val="1"/>
+  <c:style val="2"/>
   <c:chart>
     <c:title>
       <c:tx>
@@ -624,7 +643,7 @@
               </a:defRPr>
             </a:pPr>
             <a:r>
-              <a:rPr sz="1400" b="0" i="0" u="none" strike="noStrike">
+              <a:rPr lang="en-US" sz="1400" b="0" i="0" u="none" strike="noStrike">
                 <a:solidFill>
                   <a:srgbClr val="1F2933"/>
                 </a:solidFill>
@@ -635,7 +654,6 @@
           </a:p>
         </c:rich>
       </c:tx>
-      <c:layout/>
       <c:overlay val="0"/>
     </c:title>
     <c:autoTitleDeleted val="0"/>
@@ -668,18 +686,26 @@
           <c:invertIfNegative val="0"/>
           <c:dLbls>
             <c:numFmt formatCode="0.00" sourceLinked="0"/>
+            <c:spPr>
+              <a:noFill/>
+              <a:ln>
+                <a:noFill/>
+              </a:ln>
+              <a:effectLst/>
+            </c:spPr>
             <c:txPr>
               <a:bodyPr/>
               <a:lstStyle/>
               <a:p>
                 <a:pPr>
-                  <a:defRPr b="0" i="0" strike="noStrike" sz="1100" u="none">
+                  <a:defRPr sz="1100" b="0" i="0" u="none" strike="noStrike">
                     <a:solidFill>
                       <a:srgbClr val="1F2933"/>
                     </a:solidFill>
                     <a:latin typeface="Arial"/>
                   </a:defRPr>
                 </a:pPr>
+                <a:endParaRPr lang="en-US"/>
               </a:p>
             </c:txPr>
             <c:showLegendKey val="0"/>
@@ -689,55 +715,58 @@
             <c:showPercent val="0"/>
             <c:showBubbleSize val="0"/>
             <c:showLeaderLines val="0"/>
+            <c:extLst>
+              <c:ext xmlns:c15="http://schemas.microsoft.com/office/drawing/2012/chart" uri="{CE6537A1-D6FC-4f65-9D91-7224C49458BB}">
+                <c15:showLeaderLines val="0"/>
+              </c:ext>
+            </c:extLst>
           </c:dLbls>
           <c:cat>
-            <c:multiLvlStrRef>
+            <c:strRef>
               <c:f>Sheet1!$A$2:$A$14</c:f>
-              <c:multiLvlStrCache>
+              <c:strCache>
                 <c:ptCount val="13"/>
-                <c:lvl>
-                  <c:pt idx="0">
-                    <c:v>Fashion-MNIST</c:v>
-                  </c:pt>
-                  <c:pt idx="1">
-                    <c:v>DBpedia</c:v>
-                  </c:pt>
-                  <c:pt idx="2">
-                    <c:v>COCO-I2I</c:v>
-                  </c:pt>
-                  <c:pt idx="3">
-                    <c:v>LAION</c:v>
-                  </c:pt>
-                  <c:pt idx="4">
-                    <c:v>Yambda</c:v>
-                  </c:pt>
-                  <c:pt idx="5">
-                    <c:v>SIFT-1M</c:v>
-                  </c:pt>
-                  <c:pt idx="6">
-                    <c:v>Yahoo-MiniLM</c:v>
-                  </c:pt>
-                  <c:pt idx="7">
-                    <c:v>Deep1B</c:v>
-                  </c:pt>
-                  <c:pt idx="8">
-                    <c:v>Cohere</c:v>
-                  </c:pt>
-                  <c:pt idx="9">
-                    <c:v>BIGANN</c:v>
-                  </c:pt>
-                  <c:pt idx="10">
-                    <c:v>GIST</c:v>
-                  </c:pt>
-                  <c:pt idx="11">
-                    <c:v>MS Turing</c:v>
-                  </c:pt>
-                  <c:pt idx="12">
-                    <c:v>MS MARCO</c:v>
-                  </c:pt>
-                </c:lvl>
-              </c:multiLvlStrCache>
-            </c:multiLvlStrRef>
+                <c:pt idx="0">
+                  <c:v>Fashion-MNIST</c:v>
+                </c:pt>
+                <c:pt idx="1">
+                  <c:v>DBpedia</c:v>
+                </c:pt>
+                <c:pt idx="2">
+                  <c:v>COCO-I2I</c:v>
+                </c:pt>
+                <c:pt idx="3">
+                  <c:v>LAION</c:v>
+                </c:pt>
+                <c:pt idx="4">
+                  <c:v>Yambda</c:v>
+                </c:pt>
+                <c:pt idx="5">
+                  <c:v>SIFT-1M</c:v>
+                </c:pt>
+                <c:pt idx="6">
+                  <c:v>Yahoo-MiniLM</c:v>
+                </c:pt>
+                <c:pt idx="7">
+                  <c:v>Deep1B</c:v>
+                </c:pt>
+                <c:pt idx="8">
+                  <c:v>Cohere</c:v>
+                </c:pt>
+                <c:pt idx="9">
+                  <c:v>BIGANN</c:v>
+                </c:pt>
+                <c:pt idx="10">
+                  <c:v>GIST</c:v>
+                </c:pt>
+                <c:pt idx="11">
+                  <c:v>MS Turing</c:v>
+                </c:pt>
+                <c:pt idx="12">
+                  <c:v>MS MARCO</c:v>
+                </c:pt>
+              </c:strCache>
+            </c:strRef>
           </c:cat>
           <c:val>
             <c:numRef>
@@ -773,10 +802,10 @@
                   <c:v>1.18</c:v>
                 </c:pt>
                 <c:pt idx="9">
-                  <c:v>1.11</c:v>
+                  <c:v>1.1100000000000001</c:v>
                 </c:pt>
                 <c:pt idx="10">
-                  <c:v>1.1</c:v>
+                  <c:v>1.1000000000000001</c:v>
                 </c:pt>
                 <c:pt idx="11">
                   <c:v>1.08</c:v>
@@ -787,36 +816,23 @@
               </c:numCache>
             </c:numRef>
           </c:val>
+          <c:extLst>
+            <c:ext xmlns:c16="http://schemas.microsoft.com/office/drawing/2014/chart" uri="{C3380CC4-5D6E-409C-BE32-E72D297353CC}">
+              <c16:uniqueId val="{00000000-8945-45BB-8AAB-81E9B3D7506C}"/>
+            </c:ext>
+          </c:extLst>
         </c:ser>
         <c:dLbls>
-          <c:numFmt formatCode="0.00" sourceLinked="0"/>
-          <c:txPr>
-            <a:bodyPr/>
-            <a:lstStyle/>
-            <a:p>
-              <a:pPr>
-                <a:defRPr b="0" i="0" strike="noStrike" sz="1100" u="none">
-                  <a:solidFill>
-                    <a:srgbClr val="1F2933"/>
-                  </a:solidFill>
-                  <a:latin typeface="Arial"/>
-                </a:defRPr>
-              </a:pPr>
-            </a:p>
-          </c:txPr>
           <c:showLegendKey val="0"/>
           <c:showVal val="1"/>
           <c:showCatName val="0"/>
           <c:showSerName val="0"/>
           <c:showPercent val="0"/>
           <c:showBubbleSize val="0"/>
-          <c:showLeaderLines val="0"/>
         </c:dLbls>
         <c:gapWidth val="150"/>
-        <c:overlap val="0"/>
         <c:axId val="2094734554"/>
         <c:axId val="2094734552"/>
-        <c:axId val="2094734556"/>
       </c:barChart>
       <c:catAx>
         <c:axId val="2094734554"/>
@@ -857,6 +873,7 @@
         <c:crosses val="autoZero"/>
         <c:auto val="1"/>
         <c:lblAlgn val="ctr"/>
+        <c:lblOffset val="100"/>
         <c:noMultiLvlLbl val="1"/>
       </c:catAx>
       <c:valAx>
@@ -866,7 +883,7 @@
           <c:min val="0"/>
         </c:scaling>
         <c:delete val="0"/>
-        <c:axPos val="b"/>
+        <c:axPos val="t"/>
         <c:majorGridlines>
           <c:spPr>
             <a:ln w="9525" cap="flat">
@@ -920,6 +937,7 @@
     </c:plotArea>
     <c:plotVisOnly val="1"/>
     <c:dispBlanksAs val="span"/>
+    <c:showDLblsOverMax val="1"/>
   </c:chart>
   <c:spPr>
     <a:noFill/>
@@ -956,234 +974,10 @@
           <a:chExt cx="0" cy="0"/>
         </a:xfrm>
       </p:grpSpPr>
-      <p:sp>
-        <p:nvSpPr>
-          <p:cNvPr id="2" name="Header Placeholder 1"/>
-          <p:cNvSpPr>
-            <a:spLocks noGrp="1"/>
-          </p:cNvSpPr>
-          <p:nvPr>
-            <p:ph type="hdr" sz="quarter"/>
-          </p:nvPr>
-        </p:nvSpPr>
-        <p:spPr>
-          <a:xfrm>
-            <a:off x="0" y="0"/>
-            <a:ext cx="2971800" cy="458788"/>
-          </a:xfrm>
-          <a:prstGeom prst="rect">
-            <a:avLst/>
-          </a:prstGeom>
-        </p:spPr>
-        <p:txBody>
-          <a:bodyPr vert="horz" lIns="91440" tIns="45720" rIns="91440" bIns="45720" rtlCol="0"/>
-          <a:lstStyle>
-            <a:lvl1pPr algn="l">
-              <a:defRPr sz="1200"/>
-            </a:lvl1pPr>
-          </a:lstStyle>
-          <a:p>
-            <a:endParaRPr lang="en-US"/>
-          </a:p>
-        </p:txBody>
-      </p:sp>
-      <p:sp>
-        <p:nvSpPr>
-          <p:cNvPr id="3" name="Date Placeholder 2"/>
-          <p:cNvSpPr>
-            <a:spLocks noGrp="1"/>
-          </p:cNvSpPr>
-          <p:nvPr>
-            <p:ph type="dt" idx="1"/>
-          </p:nvPr>
-        </p:nvSpPr>
-        <p:spPr>
-          <a:xfrm>
-            <a:off x="3884613" y="0"/>
-            <a:ext cx="2971800" cy="458788"/>
-          </a:xfrm>
-          <a:prstGeom prst="rect">
-            <a:avLst/>
-          </a:prstGeom>
-        </p:spPr>
-        <p:txBody>
-          <a:bodyPr vert="horz" lIns="91440" tIns="45720" rIns="91440" bIns="45720" rtlCol="0"/>
-          <a:lstStyle>
-            <a:lvl1pPr algn="r">
-              <a:defRPr sz="1200"/>
-            </a:lvl1pPr>
-          </a:lstStyle>
-          <a:p>
-            <a:fld id="{5282F153-3F37-0F45-9E97-73ACFA13230C}" type="datetimeFigureOut">
-              <a:rPr lang="en-US"/>
-              <a:t>7/23/19</a:t>
-            </a:fld>
-            <a:endParaRPr lang="en-US"/>
-          </a:p>
-        </p:txBody>
-      </p:sp>
-      <p:sp>
-        <p:nvSpPr>
-          <p:cNvPr id="4" name="Slide Image Placeholder 3"/>
-          <p:cNvSpPr>
-            <a:spLocks noGrp="1" noRot="1" noChangeAspect="1"/>
-          </p:cNvSpPr>
-          <p:nvPr>
-            <p:ph type="sldImg" idx="2"/>
-          </p:nvPr>
-        </p:nvSpPr>
-        <p:spPr>
-          <a:xfrm>
-            <a:off x="685800" y="1143000"/>
-            <a:ext cx="5486400" cy="3086100"/>
-          </a:xfrm>
-          <a:prstGeom prst="rect">
-            <a:avLst/>
-          </a:prstGeom>
-          <a:noFill/>
-          <a:ln w="12700">
-            <a:solidFill>
-              <a:prstClr val="black"/>
-            </a:solidFill>
-          </a:ln>
-        </p:spPr>
-        <p:txBody>
-          <a:bodyPr vert="horz" lIns="91440" tIns="45720" rIns="91440" bIns="45720" rtlCol="0" anchor="ctr"/>
-          <a:lstStyle/>
-          <a:p>
-            <a:endParaRPr lang="en-US"/>
-          </a:p>
-        </p:txBody>
-      </p:sp>
-      <p:sp>
-        <p:nvSpPr>
-          <p:cNvPr id="5" name="Notes Placeholder 4"/>
-          <p:cNvSpPr>
-            <a:spLocks noGrp="1"/>
-          </p:cNvSpPr>
-          <p:nvPr>
-            <p:ph type="body" sz="quarter" idx="3"/>
-          </p:nvPr>
-        </p:nvSpPr>
-        <p:spPr>
-          <a:xfrm>
-            <a:off x="685800" y="4400550"/>
-            <a:ext cx="5486400" cy="3600450"/>
-          </a:xfrm>
-          <a:prstGeom prst="rect">
-            <a:avLst/>
-          </a:prstGeom>
-        </p:spPr>
-        <p:txBody>
-          <a:bodyPr vert="horz" lIns="91440" tIns="45720" rIns="91440" bIns="45720" rtlCol="0"/>
-          <a:lstStyle/>
-          <a:p>
-            <a:pPr lvl="0"/>
-            <a:r>
-              <a:rPr lang="en-US"/>
-              <a:t>Click to edit Master text styles</a:t>
-            </a:r>
-          </a:p>
-          <a:p>
-            <a:pPr lvl="1"/>
-            <a:r>
-              <a:rPr lang="en-US"/>
-              <a:t>Second level</a:t>
-            </a:r>
-          </a:p>
-          <a:p>
-            <a:pPr lvl="2"/>
-            <a:r>
-              <a:rPr lang="en-US"/>
-              <a:t>Third level</a:t>
-            </a:r>
-          </a:p>
-          <a:p>
-            <a:pPr lvl="3"/>
-            <a:r>
-              <a:rPr lang="en-US"/>
-              <a:t>Fourth level</a:t>
-            </a:r>
-          </a:p>
-          <a:p>
-            <a:pPr lvl="4"/>
-            <a:r>
-              <a:rPr lang="en-US"/>
-              <a:t>Fifth level</a:t>
-            </a:r>
-          </a:p>
-        </p:txBody>
-      </p:sp>
-      <p:sp>
-        <p:nvSpPr>
-          <p:cNvPr id="6" name="Footer Placeholder 5"/>
-          <p:cNvSpPr>
-            <a:spLocks noGrp="1"/>
-          </p:cNvSpPr>
-          <p:nvPr>
-            <p:ph type="ftr" sz="quarter" idx="4"/>
-          </p:nvPr>
-        </p:nvSpPr>
-        <p:spPr>
-          <a:xfrm>
-            <a:off x="0" y="8685213"/>
-            <a:ext cx="2971800" cy="458787"/>
-          </a:xfrm>
-          <a:prstGeom prst="rect">
-            <a:avLst/>
-          </a:prstGeom>
-        </p:spPr>
-        <p:txBody>
-          <a:bodyPr vert="horz" lIns="91440" tIns="45720" rIns="91440" bIns="45720" rtlCol="0" anchor="b"/>
-          <a:lstStyle>
-            <a:lvl1pPr algn="l">
-              <a:defRPr sz="1200"/>
-            </a:lvl1pPr>
-          </a:lstStyle>
-          <a:p>
-            <a:endParaRPr lang="en-US"/>
-          </a:p>
-        </p:txBody>
-      </p:sp>
-      <p:sp>
-        <p:nvSpPr>
-          <p:cNvPr id="7" name="Slide Number Placeholder 6"/>
-          <p:cNvSpPr>
-            <a:spLocks noGrp="1"/>
-          </p:cNvSpPr>
-          <p:nvPr>
-            <p:ph type="sldNum" sz="quarter" idx="5"/>
-          </p:nvPr>
-        </p:nvSpPr>
-        <p:spPr>
-          <a:xfrm>
-            <a:off x="3884613" y="8685213"/>
-            <a:ext cx="2971800" cy="458787"/>
-          </a:xfrm>
-          <a:prstGeom prst="rect">
-            <a:avLst/>
-          </a:prstGeom>
-        </p:spPr>
-        <p:txBody>
-          <a:bodyPr vert="horz" lIns="91440" tIns="45720" rIns="91440" bIns="45720" rtlCol="0" anchor="b"/>
-          <a:lstStyle>
-            <a:lvl1pPr algn="r">
-              <a:defRPr sz="1200"/>
-            </a:lvl1pPr>
-          </a:lstStyle>
-          <a:p>
-            <a:fld id="{CE5E9CC1-C706-0F49-92D6-E571CC5EEA8F}" type="slidenum">
-              <a:rPr lang="en-US"/>
-              <a:t>‹#›</a:t>
-            </a:fld>
-            <a:endParaRPr lang="en-US"/>
-          </a:p>
-        </p:txBody>
-      </p:sp>
     </p:spTree>
     <p:extLst>
       <p:ext uri="{BB962C8B-B14F-4D97-AF65-F5344CB8AC3E}">
-        <p14:creationId xmlns:p14="http://schemas.microsoft.com/office/powerpoint/2010/main" val="1024086991"/>
+        <p14:creationId xmlns:p14="http://schemas.microsoft.com/office/powerpoint/2010/main" val="4292724455"/>
       </p:ext>
     </p:extLst>
   </p:cSld>
@@ -1331,7 +1125,6 @@
               <a:rPr lang="en-US" dirty="0"/>
               <a:t>(0:05) Hi, we are [team]. Our project is PercEF: making adaptive vector search work when the data is not bell-shaped.</a:t>
             </a:r>
-            <a:endParaRPr lang="en-US" dirty="0"/>
           </a:p>
         </p:txBody>
       </p:sp>
@@ -1419,7 +1212,6 @@
               <a:rPr lang="en-US" dirty="0"/>
               <a:t>(0:05) We followed Ada-ef's own protocol on 20 datasets and compared everything against the best fixed ef.</a:t>
             </a:r>
-            <a:endParaRPr lang="en-US" dirty="0"/>
           </a:p>
         </p:txBody>
       </p:sp>
@@ -1507,7 +1299,6 @@
               <a:rPr lang="en-US" dirty="0"/>
               <a:t>(0:10) Each pair of bars is a dataset; longer to the right is better. On the non-Gaussian datasets PercEF ranks queries better in every run and beats Ada-ef's worst case in 15 of 16: on DeepImage by 8.5 recall points, against 4.3. To match that worst case, a fixed ef is slower in 13 of 16 runs.</a:t>
             </a:r>
-            <a:endParaRPr lang="en-US" dirty="0"/>
           </a:p>
         </p:txBody>
       </p:sp>
@@ -1595,7 +1386,6 @@
               <a:rPr lang="en-US" dirty="0"/>
               <a:t>(0:10) PercEF does less work than the best fixed ef in 32 of 34 runs, never more than 2.5 percent extra. Matched on the worst case, it is faster than the fixed ef in 31 of 34 runs, and up to 1.8 times faster than Ada-ef. On bell-shaped data it is cheaper and faster in every run; Ada-ef's advantage there is a larger worst-case gain.</a:t>
             </a:r>
-            <a:endParaRPr lang="en-US" dirty="0"/>
           </a:p>
         </p:txBody>
       </p:sp>
@@ -1683,7 +1473,6 @@
               <a:rPr lang="en-US" dirty="0"/>
               <a:t>(0:08) The gain comes from the thresholds, not the shorter probe. The learned method DARTH has a better worst case, but is up to 2.3 times slower.</a:t>
             </a:r>
-            <a:endParaRPr lang="en-US" dirty="0"/>
           </a:p>
         </p:txBody>
       </p:sp>
@@ -1771,7 +1560,6 @@
               <a:rPr lang="en-US" dirty="0"/>
               <a:t>(hidden slide, skipped when presenting) Tested idea that did not hold: PercEF's score with Ada-ef's table.</a:t>
             </a:r>
-            <a:endParaRPr lang="en-US" dirty="0"/>
           </a:p>
         </p:txBody>
       </p:sp>
@@ -1859,7 +1647,6 @@
               <a:rPr lang="en-US" dirty="0"/>
               <a:t>(0:06) On bell-shaped text data Ada-ef gives larger worst-case gains, on DeepImage PercEF is a few percent slower than the fixed ef at the same mean recall, and cross-modal queries remain open.</a:t>
             </a:r>
-            <a:endParaRPr lang="en-US" dirty="0"/>
           </a:p>
         </p:txBody>
       </p:sp>
@@ -1947,7 +1734,6 @@
               <a:rPr lang="en-US" dirty="0"/>
               <a:t>(0:05) In short: measure the distribution, don't assume it. Thank you.</a:t>
             </a:r>
-            <a:endParaRPr lang="en-US" dirty="0"/>
           </a:p>
         </p:txBody>
       </p:sp>
@@ -2035,7 +1821,6 @@
               <a:rPr lang="en-US" dirty="0"/>
               <a:t>(0:12) Vector search finds the items closest to a query among millions of embeddings. To be fast, an index like HNSW walks a layered graph from the top down. A setting called ef decides how many candidates the search keeps: more is more accurate, but slower.</a:t>
             </a:r>
-            <a:endParaRPr lang="en-US" dirty="0"/>
           </a:p>
         </p:txBody>
       </p:sp>
@@ -2123,7 +1908,6 @@
               <a:rPr lang="en-US" dirty="0"/>
               <a:t>(0:08) Most systems use one ef for every query. Easy queries waste work, and hard queries miss some of their neighbours.</a:t>
             </a:r>
-            <a:endParaRPr lang="en-US" dirty="0"/>
           </a:p>
         </p:txBody>
       </p:sp>
@@ -2211,7 +1995,6 @@
               <a:rPr lang="en-US" dirty="0"/>
               <a:t>(0:08) Existing fixes either train a model per dataset, like DARTH, or, like Ada-ef from SIGMOD 2026, assume that a query's similarities follow a bell curve.</a:t>
             </a:r>
-            <a:endParaRPr lang="en-US" dirty="0"/>
           </a:p>
         </p:txBody>
       </p:sp>
@@ -2299,7 +2082,6 @@
               <a:rPr lang="en-US" dirty="0"/>
               <a:t>(0:08) Ada-ef places its difficulty thresholds using that bell curve. Nobody had checked whether real data is bell-shaped.</a:t>
             </a:r>
-            <a:endParaRPr lang="en-US" dirty="0"/>
           </a:p>
         </p:txBody>
       </p:sp>
@@ -2387,7 +2169,6 @@
               <a:rPr lang="en-US" dirty="0"/>
               <a:t>(0:10) We tested it on 41 datasets. Nine are clearly not bell-shaped, including SIFT and GIST, and you cannot tell from the kind of data. On those, Ada-ef stops adapting.</a:t>
             </a:r>
-            <a:endParaRPr lang="en-US" dirty="0"/>
           </a:p>
         </p:txBody>
       </p:sp>
@@ -2475,7 +2256,6 @@
               <a:rPr lang="en-US" dirty="0"/>
               <a:t>(0:10) Our method, PercEF, keeps Ada-ef's design but measures the thresholds from the data's own distance percentiles, with a ten times shorter probe and no covariance matrix.</a:t>
             </a:r>
-            <a:endParaRPr lang="en-US" dirty="0"/>
           </a:p>
         </p:txBody>
       </p:sp>
@@ -2563,7 +2343,6 @@
               <a:rPr lang="en-US" dirty="0"/>
               <a:t>(0:08) A KS test on the raw vectors, which takes seconds, tells you which method to use. It picked the right one on 18 of 19 datasets, with every prediction written down before the run.</a:t>
             </a:r>
-            <a:endParaRPr lang="en-US" dirty="0"/>
           </a:p>
         </p:txBody>
       </p:sp>
@@ -2651,7 +2430,6 @@
               <a:rPr lang="en-US" dirty="0"/>
               <a:t>(0:08) So we contribute the first test of this assumption, a distribution-free score, a cost floor, and an offline test.</a:t>
             </a:r>
-            <a:endParaRPr lang="en-US" dirty="0"/>
           </a:p>
         </p:txBody>
       </p:sp>
@@ -2729,6 +2507,7 @@
         <a:solidFill>
           <a:schemeClr val="tx2"/>
         </a:solidFill>
+        <a:effectLst/>
       </p:bgPr>
     </p:bg>
     <p:spTree>
@@ -2748,9 +2527,11 @@
       <p:sp>
         <p:nvSpPr>
           <p:cNvPr id="2" name="Text 0"/>
-          <p:cNvSpPr/>
+          <p:cNvSpPr>
+            <a:spLocks noGrp="1"/>
+          </p:cNvSpPr>
           <p:nvPr>
-            <p:ph idx="100" type="title" hasCustomPrompt="1"/>
+            <p:ph type="title" idx="100" hasCustomPrompt="1"/>
           </p:nvPr>
         </p:nvSpPr>
         <p:spPr>
@@ -2767,7 +2548,7 @@
         <p:txBody>
           <a:bodyPr wrap="square" rtlCol="0"/>
           <a:lstStyle>
-            <a:lvl1pPr algn="l" indent="0" marL="0">
+            <a:lvl1pPr marL="0" indent="0" algn="l">
               <a:buNone/>
               <a:defRPr lang="en-US" sz="3600" b="1" dirty="0">
                 <a:solidFill>
@@ -2777,7 +2558,7 @@
             </a:lvl1pPr>
           </a:lstStyle>
           <a:p>
-            <a:pPr algn="l" indent="0" marL="0">
+            <a:pPr marL="0" indent="0" algn="l">
               <a:buNone/>
             </a:pPr>
             <a:endParaRPr lang="en-US" sz="3600" dirty="0"/>
@@ -2787,9 +2568,11 @@
       <p:sp>
         <p:nvSpPr>
           <p:cNvPr id="3" name="Text 0"/>
-          <p:cNvSpPr/>
+          <p:cNvSpPr>
+            <a:spLocks noGrp="1"/>
+          </p:cNvSpPr>
           <p:nvPr>
-            <p:ph idx="101" type="body" hasCustomPrompt="1"/>
+            <p:ph type="body" idx="101" hasCustomPrompt="1"/>
           </p:nvPr>
         </p:nvSpPr>
         <p:spPr>
@@ -2806,7 +2589,7 @@
         <p:txBody>
           <a:bodyPr wrap="square" rtlCol="0"/>
           <a:lstStyle>
-            <a:lvl1pPr indent="0" marL="0">
+            <a:lvl1pPr marL="0" indent="0">
               <a:buNone/>
               <a:defRPr lang="en-US" sz="1800" dirty="0">
                 <a:solidFill>
@@ -2816,7 +2599,7 @@
             </a:lvl1pPr>
           </a:lstStyle>
           <a:p>
-            <a:pPr indent="0" marL="0">
+            <a:pPr marL="0" indent="0">
               <a:buNone/>
             </a:pPr>
             <a:endParaRPr lang="en-US" sz="1800" dirty="0"/>
@@ -2839,6 +2622,7 @@
         <a:solidFill>
           <a:schemeClr val="bg1"/>
         </a:solidFill>
+        <a:effectLst/>
       </p:bgPr>
     </p:bg>
     <p:spTree>
@@ -2858,9 +2642,11 @@
       <p:sp>
         <p:nvSpPr>
           <p:cNvPr id="2" name="Text 0"/>
-          <p:cNvSpPr/>
+          <p:cNvSpPr>
+            <a:spLocks noGrp="1"/>
+          </p:cNvSpPr>
           <p:nvPr>
-            <p:ph idx="100" type="title" hasCustomPrompt="1"/>
+            <p:ph type="title" idx="100" hasCustomPrompt="1"/>
           </p:nvPr>
         </p:nvSpPr>
         <p:spPr>
@@ -2877,7 +2663,7 @@
         <p:txBody>
           <a:bodyPr wrap="square" rtlCol="0"/>
           <a:lstStyle>
-            <a:lvl1pPr indent="0" marL="0">
+            <a:lvl1pPr marL="0" indent="0">
               <a:buNone/>
               <a:defRPr lang="en-US" sz="3200" b="1" dirty="0">
                 <a:solidFill>
@@ -2887,7 +2673,7 @@
             </a:lvl1pPr>
           </a:lstStyle>
           <a:p>
-            <a:pPr indent="0" marL="0">
+            <a:pPr marL="0" indent="0">
               <a:buNone/>
             </a:pPr>
             <a:endParaRPr lang="en-US" sz="3200" dirty="0"/>
@@ -2915,7 +2701,7 @@
           <a:bodyPr wrap="square" lIns="0" tIns="0" rIns="0" bIns="0" rtlCol="0" anchor="ctr"/>
           <a:lstStyle/>
           <a:p>
-            <a:pPr indent="0" marL="0">
+            <a:pPr marL="0" indent="0">
               <a:buNone/>
             </a:pPr>
             <a:r>
@@ -2950,7 +2736,7 @@
           </a:prstGeom>
           <a:extLst>
             <a:ext uri="{C572A759-6A51-4108-AA02-DFA0A04FC94B}">
-              <ma14:wrappingTextBoxFlag xmlns:ma14="http://schemas.microsoft.com/office/mac/drawingml/2011/main" val="0"/>
+              <ma14:wrappingTextBoxFlag xmlns:ma14="http://schemas.microsoft.com/office/mac/drawingml/2011/main" xmlns="" val="0"/>
             </a:ext>
           </a:extLst>
         </p:spPr>
@@ -2968,8 +2754,8 @@
           <a:p>
             <a:pPr algn="l"/>
             <a:fld id="{F7021451-1387-4CA6-816F-3879F97B5CBC}" type="slidenum">
-              <a:rPr b="0" lang="en-US"/>
-              <a:t>1003</a:t>
+              <a:rPr lang="en-US" b="0"/>
+              <a:t>‹#›</a:t>
             </a:fld>
             <a:endParaRPr lang="en-US"/>
           </a:p>
@@ -2986,6 +2772,11 @@
 <file path=ppt/slideMasters/slideMaster1.xml><?xml version="1.0" encoding="utf-8"?>
 <p:sldMaster xmlns:a="http://schemas.openxmlformats.org/drawingml/2006/main" xmlns:r="http://schemas.openxmlformats.org/officeDocument/2006/relationships" xmlns:p="http://schemas.openxmlformats.org/presentationml/2006/main">
   <p:cSld>
+    <p:bg>
+      <p:bgRef idx="1001">
+        <a:schemeClr val="bg1"/>
+      </p:bgRef>
+    </p:bg>
     <p:spTree>
       <p:nvGrpSpPr>
         <p:cNvPr id="1" name=""/>
@@ -3020,7 +2811,7 @@
           </a:prstGeom>
           <a:extLst>
             <a:ext uri="{C572A759-6A51-4108-AA02-DFA0A04FC94B}">
-              <ma14:wrappingTextBoxFlag xmlns:ma14="http://schemas.microsoft.com/office/mac/drawingml/2011/main" val="0"/>
+              <ma14:wrappingTextBoxFlag xmlns:ma14="http://schemas.microsoft.com/office/mac/drawingml/2011/main" xmlns="" val="0"/>
             </a:ext>
           </a:extLst>
         </p:spPr>
@@ -3038,8 +2829,8 @@
           <a:p>
             <a:pPr algn="l"/>
             <a:fld id="{F7021451-1387-4CA6-816F-3879F97B5CBC}" type="slidenum">
-              <a:rPr b="0" lang="en-US"/>
-              <a:t>null</a:t>
+              <a:rPr lang="en-US" b="0"/>
+              <a:t>‹#›</a:t>
             </a:fld>
             <a:endParaRPr lang="en-US"/>
           </a:p>
@@ -3327,9 +3118,11 @@
       <p:sp>
         <p:nvSpPr>
           <p:cNvPr id="2" name="Text 0"/>
-          <p:cNvSpPr/>
+          <p:cNvSpPr>
+            <a:spLocks noGrp="1"/>
+          </p:cNvSpPr>
           <p:nvPr>
-            <p:ph idx="100" type="title" hasCustomPrompt="1"/>
+            <p:ph type="title" idx="100" hasCustomPrompt="1"/>
           </p:nvPr>
         </p:nvSpPr>
         <p:spPr>
@@ -3347,7 +3140,7 @@
           <a:bodyPr wrap="square" lIns="0" tIns="0" rIns="0" bIns="0" rtlCol="0" anchor="b"/>
           <a:lstStyle/>
           <a:p>
-            <a:pPr algn="l" indent="0" marL="0">
+            <a:pPr marL="0" indent="0" algn="l">
               <a:buNone/>
             </a:pPr>
             <a:r>
@@ -3365,9 +3158,11 @@
       <p:sp>
         <p:nvSpPr>
           <p:cNvPr id="3" name="Text 0"/>
-          <p:cNvSpPr/>
+          <p:cNvSpPr>
+            <a:spLocks noGrp="1"/>
+          </p:cNvSpPr>
           <p:nvPr>
-            <p:ph idx="101" type="body" hasCustomPrompt="1"/>
+            <p:ph type="body" idx="101" hasCustomPrompt="1"/>
           </p:nvPr>
         </p:nvSpPr>
         <p:spPr>
@@ -3385,7 +3180,7 @@
           <a:bodyPr wrap="square" lIns="0" tIns="0" rIns="0" bIns="0" rtlCol="0" anchor="t"/>
           <a:lstStyle/>
           <a:p>
-            <a:pPr indent="0" marL="0">
+            <a:pPr marL="0" indent="0">
               <a:spcAft>
                 <a:spcPts val="1000"/>
               </a:spcAft>
@@ -3402,7 +3197,7 @@
             <a:endParaRPr lang="en-US" sz="1800" dirty="0"/>
           </a:p>
           <a:p>
-            <a:pPr indent="0" marL="0">
+            <a:pPr marL="0" indent="0">
               <a:buNone/>
             </a:pPr>
             <a:r>
@@ -3416,7 +3211,7 @@
             <a:endParaRPr lang="en-US" sz="1800" dirty="0"/>
           </a:p>
           <a:p>
-            <a:pPr indent="0" marL="0">
+            <a:pPr marL="0" indent="0">
               <a:buNone/>
             </a:pPr>
             <a:r>
@@ -3430,7 +3225,7 @@
             <a:endParaRPr lang="en-US" sz="1800" dirty="0"/>
           </a:p>
           <a:p>
-            <a:pPr indent="0" marL="0">
+            <a:pPr marL="0" indent="0">
               <a:buNone/>
             </a:pPr>
             <a:r>
@@ -3474,14 +3269,14 @@
       </p:sp>
       <p:pic>
         <p:nvPicPr>
-          <p:cNvPr id="5" name="PES logo" descr="E:\shenvipranav\projects\hybridAdaEf\poster\assets\logo_pes.png">    </p:cNvPr>
+          <p:cNvPr id="5" name="PES logo" descr="E:\shenvipranav\projects\hybridAdaEf\poster\assets\logo_pes.png"/>
           <p:cNvPicPr>
             <a:picLocks noChangeAspect="1"/>
           </p:cNvPicPr>
           <p:nvPr/>
         </p:nvPicPr>
         <p:blipFill>
-          <a:blip r:embed="rId1"/>
+          <a:blip r:embed="rId3"/>
           <a:stretch>
             <a:fillRect/>
           </a:stretch>
@@ -3524,9 +3319,11 @@
       <p:sp>
         <p:nvSpPr>
           <p:cNvPr id="2" name="Text 0"/>
-          <p:cNvSpPr/>
+          <p:cNvSpPr>
+            <a:spLocks noGrp="1"/>
+          </p:cNvSpPr>
           <p:nvPr>
-            <p:ph idx="100" type="title" hasCustomPrompt="1"/>
+            <p:ph type="title" idx="100" hasCustomPrompt="1"/>
           </p:nvPr>
         </p:nvSpPr>
         <p:spPr>
@@ -3544,7 +3341,7 @@
           <a:bodyPr wrap="square" lIns="0" tIns="0" rIns="0" bIns="0" rtlCol="0" anchor="ctr"/>
           <a:lstStyle/>
           <a:p>
-            <a:pPr indent="0" marL="0">
+            <a:pPr marL="0" indent="0">
               <a:buNone/>
             </a:pPr>
             <a:r>
@@ -3687,15 +3484,27 @@
         </p:nvGraphicFramePr>
         <p:xfrm>
           <a:off x="5943600" y="1280160"/>
-          <a:ext cx="5715000" cy="914400"/>
+          <a:ext cx="5715000" cy="2243328"/>
         </p:xfrm>
         <a:graphic>
           <a:graphicData uri="http://schemas.openxmlformats.org/drawingml/2006/table">
             <a:tbl>
               <a:tblPr/>
               <a:tblGrid>
-                <a:gridCol w="1920240"/>
-                <a:gridCol w="3794760"/>
+                <a:gridCol w="1920240">
+                  <a:extLst>
+                    <a:ext uri="{9D8B030D-6E8A-4147-A177-3AD203B41FA5}">
+                      <a16:colId xmlns:a16="http://schemas.microsoft.com/office/drawing/2014/main" val="20000"/>
+                    </a:ext>
+                  </a:extLst>
+                </a:gridCol>
+                <a:gridCol w="3794760">
+                  <a:extLst>
+                    <a:ext uri="{9D8B030D-6E8A-4147-A177-3AD203B41FA5}">
+                      <a16:colId xmlns:a16="http://schemas.microsoft.com/office/drawing/2014/main" val="20001"/>
+                    </a:ext>
+                  </a:extLst>
+                </a:gridCol>
               </a:tblGrid>
               <a:tr h="0">
                 <a:tc>
@@ -3703,7 +3512,7 @@
                     <a:bodyPr/>
                     <a:lstStyle/>
                     <a:p>
-                      <a:pPr indent="0" marL="0">
+                      <a:pPr marL="0" indent="0">
                         <a:buNone/>
                       </a:pPr>
                       <a:r>
@@ -3771,7 +3580,7 @@
                     <a:bodyPr/>
                     <a:lstStyle/>
                     <a:p>
-                      <a:pPr indent="0" marL="0">
+                      <a:pPr marL="0" indent="0">
                         <a:buNone/>
                       </a:pPr>
                       <a:r>
@@ -3834,6 +3643,11 @@
                     </a:solidFill>
                   </a:tcPr>
                 </a:tc>
+                <a:extLst>
+                  <a:ext uri="{0D108BD9-81ED-4DB2-BD59-A6C34878D82A}">
+                    <a16:rowId xmlns:a16="http://schemas.microsoft.com/office/drawing/2014/main" val="10000"/>
+                  </a:ext>
+                </a:extLst>
               </a:tr>
               <a:tr h="0">
                 <a:tc>
@@ -3841,7 +3655,7 @@
                     <a:bodyPr/>
                     <a:lstStyle/>
                     <a:p>
-                      <a:pPr indent="0" marL="0">
+                      <a:pPr marL="0" indent="0">
                         <a:buNone/>
                       </a:pPr>
                       <a:r>
@@ -3909,7 +3723,7 @@
                     <a:bodyPr/>
                     <a:lstStyle/>
                     <a:p>
-                      <a:pPr indent="0" marL="0">
+                      <a:pPr marL="0" indent="0">
                         <a:buNone/>
                       </a:pPr>
                       <a:r>
@@ -3972,6 +3786,11 @@
                     </a:solidFill>
                   </a:tcPr>
                 </a:tc>
+                <a:extLst>
+                  <a:ext uri="{0D108BD9-81ED-4DB2-BD59-A6C34878D82A}">
+                    <a16:rowId xmlns:a16="http://schemas.microsoft.com/office/drawing/2014/main" val="10001"/>
+                  </a:ext>
+                </a:extLst>
               </a:tr>
               <a:tr h="0">
                 <a:tc>
@@ -3979,7 +3798,7 @@
                     <a:bodyPr/>
                     <a:lstStyle/>
                     <a:p>
-                      <a:pPr indent="0" marL="0">
+                      <a:pPr marL="0" indent="0">
                         <a:buNone/>
                       </a:pPr>
                       <a:r>
@@ -4047,7 +3866,7 @@
                     <a:bodyPr/>
                     <a:lstStyle/>
                     <a:p>
-                      <a:pPr indent="0" marL="0">
+                      <a:pPr marL="0" indent="0">
                         <a:buNone/>
                       </a:pPr>
                       <a:r>
@@ -4110,6 +3929,11 @@
                     </a:solidFill>
                   </a:tcPr>
                 </a:tc>
+                <a:extLst>
+                  <a:ext uri="{0D108BD9-81ED-4DB2-BD59-A6C34878D82A}">
+                    <a16:rowId xmlns:a16="http://schemas.microsoft.com/office/drawing/2014/main" val="10002"/>
+                  </a:ext>
+                </a:extLst>
               </a:tr>
               <a:tr h="0">
                 <a:tc>
@@ -4117,7 +3941,7 @@
                     <a:bodyPr/>
                     <a:lstStyle/>
                     <a:p>
-                      <a:pPr indent="0" marL="0">
+                      <a:pPr marL="0" indent="0">
                         <a:buNone/>
                       </a:pPr>
                       <a:r>
@@ -4185,7 +4009,7 @@
                     <a:bodyPr/>
                     <a:lstStyle/>
                     <a:p>
-                      <a:pPr indent="0" marL="0">
+                      <a:pPr marL="0" indent="0">
                         <a:buNone/>
                       </a:pPr>
                       <a:r>
@@ -4248,6 +4072,11 @@
                     </a:solidFill>
                   </a:tcPr>
                 </a:tc>
+                <a:extLst>
+                  <a:ext uri="{0D108BD9-81ED-4DB2-BD59-A6C34878D82A}">
+                    <a16:rowId xmlns:a16="http://schemas.microsoft.com/office/drawing/2014/main" val="10003"/>
+                  </a:ext>
+                </a:extLst>
               </a:tr>
               <a:tr h="0">
                 <a:tc>
@@ -4255,7 +4084,7 @@
                     <a:bodyPr/>
                     <a:lstStyle/>
                     <a:p>
-                      <a:pPr indent="0" marL="0">
+                      <a:pPr marL="0" indent="0">
                         <a:buNone/>
                       </a:pPr>
                       <a:r>
@@ -4323,7 +4152,7 @@
                     <a:bodyPr/>
                     <a:lstStyle/>
                     <a:p>
-                      <a:pPr indent="0" marL="0">
+                      <a:pPr marL="0" indent="0">
                         <a:buNone/>
                       </a:pPr>
                       <a:r>
@@ -4386,6 +4215,11 @@
                     </a:solidFill>
                   </a:tcPr>
                 </a:tc>
+                <a:extLst>
+                  <a:ext uri="{0D108BD9-81ED-4DB2-BD59-A6C34878D82A}">
+                    <a16:rowId xmlns:a16="http://schemas.microsoft.com/office/drawing/2014/main" val="10004"/>
+                  </a:ext>
+                </a:extLst>
               </a:tr>
               <a:tr h="0">
                 <a:tc>
@@ -4393,7 +4227,7 @@
                     <a:bodyPr/>
                     <a:lstStyle/>
                     <a:p>
-                      <a:pPr indent="0" marL="0">
+                      <a:pPr marL="0" indent="0">
                         <a:buNone/>
                       </a:pPr>
                       <a:r>
@@ -4461,7 +4295,7 @@
                     <a:bodyPr/>
                     <a:lstStyle/>
                     <a:p>
-                      <a:pPr indent="0" marL="0">
+                      <a:pPr marL="0" indent="0">
                         <a:buNone/>
                       </a:pPr>
                       <a:r>
@@ -4524,6 +4358,11 @@
                     </a:solidFill>
                   </a:tcPr>
                 </a:tc>
+                <a:extLst>
+                  <a:ext uri="{0D108BD9-81ED-4DB2-BD59-A6C34878D82A}">
+                    <a16:rowId xmlns:a16="http://schemas.microsoft.com/office/drawing/2014/main" val="10005"/>
+                  </a:ext>
+                </a:extLst>
               </a:tr>
             </a:tbl>
           </a:graphicData>
@@ -4549,7 +4388,7 @@
           </a:prstGeom>
           <a:extLst>
             <a:ext uri="{C572A759-6A51-4108-AA02-DFA0A04FC94B}">
-              <ma14:wrappingTextBoxFlag xmlns:ma14="http://schemas.microsoft.com/office/mac/drawingml/2011/main" val="0"/>
+              <ma14:wrappingTextBoxFlag xmlns:ma14="http://schemas.microsoft.com/office/mac/drawingml/2011/main" xmlns="" val="0"/>
             </a:ext>
           </a:extLst>
         </p:spPr>
@@ -4567,7 +4406,7 @@
           <a:p>
             <a:pPr algn="l"/>
             <a:fld id="{F7021451-1387-4CA6-816F-3879F97B5CBC}" type="slidenum">
-              <a:rPr b="0" lang="en-US"/>
+              <a:rPr lang="en-US" b="0"/>
               <a:t>10</a:t>
             </a:fld>
             <a:endParaRPr lang="en-US"/>
@@ -4602,9 +4441,11 @@
       <p:sp>
         <p:nvSpPr>
           <p:cNvPr id="2" name="Text 0"/>
-          <p:cNvSpPr/>
+          <p:cNvSpPr>
+            <a:spLocks noGrp="1"/>
+          </p:cNvSpPr>
           <p:nvPr>
-            <p:ph idx="100" type="title" hasCustomPrompt="1"/>
+            <p:ph type="title" idx="100" hasCustomPrompt="1"/>
           </p:nvPr>
         </p:nvSpPr>
         <p:spPr>
@@ -4622,7 +4463,7 @@
           <a:bodyPr wrap="square" lIns="0" tIns="0" rIns="0" bIns="0" rtlCol="0" anchor="ctr"/>
           <a:lstStyle/>
           <a:p>
-            <a:pPr indent="0" marL="0">
+            <a:pPr marL="0" indent="0">
               <a:buNone/>
             </a:pPr>
             <a:r>
@@ -4639,7 +4480,7 @@
       </p:sp>
       <p:graphicFrame>
         <p:nvGraphicFramePr>
-          <p:cNvPr id="3" name="p1 gain chart" descr=""/>
+          <p:cNvPr id="3" name="p1 gain chart"/>
           <p:cNvGraphicFramePr/>
           <p:nvPr/>
         </p:nvGraphicFramePr>
@@ -4647,9 +4488,9 @@
           <a:off x="548640" y="1234440"/>
           <a:ext cx="7498080" cy="4937760"/>
         </p:xfrm>
-        <a:graphic xmlns:a="http://schemas.openxmlformats.org/drawingml/2006/main">
+        <a:graphic>
           <a:graphicData uri="http://schemas.openxmlformats.org/drawingml/2006/chart">
-            <c:chart xmlns:c="http://schemas.openxmlformats.org/drawingml/2006/chart" r:id="rId1"/>
+            <c:chart xmlns:c="http://schemas.openxmlformats.org/drawingml/2006/chart" xmlns:r="http://schemas.openxmlformats.org/officeDocument/2006/relationships" r:id="rId3"/>
           </a:graphicData>
         </a:graphic>
       </p:graphicFrame>
@@ -4674,7 +4515,7 @@
           <a:bodyPr wrap="square" lIns="0" tIns="0" rIns="0" bIns="0" rtlCol="0" anchor="ctr"/>
           <a:lstStyle/>
           <a:p>
-            <a:pPr indent="0" marL="0">
+            <a:pPr marL="0" indent="0">
               <a:buNone/>
             </a:pPr>
             <a:r>
@@ -4713,7 +4554,7 @@
           <a:bodyPr wrap="square" lIns="0" tIns="0" rIns="0" bIns="0" rtlCol="0" anchor="t"/>
           <a:lstStyle/>
           <a:p>
-            <a:pPr indent="0" marL="0">
+            <a:pPr marL="0" indent="0">
               <a:buNone/>
             </a:pPr>
             <a:r>
@@ -4749,7 +4590,7 @@
           <a:bodyPr wrap="square" lIns="0" tIns="0" rIns="0" bIns="0" rtlCol="0" anchor="ctr"/>
           <a:lstStyle/>
           <a:p>
-            <a:pPr indent="0" marL="0">
+            <a:pPr marL="0" indent="0">
               <a:buNone/>
             </a:pPr>
             <a:r>
@@ -4788,7 +4629,7 @@
           <a:bodyPr wrap="square" lIns="0" tIns="0" rIns="0" bIns="0" rtlCol="0" anchor="t"/>
           <a:lstStyle/>
           <a:p>
-            <a:pPr indent="0" marL="0">
+            <a:pPr marL="0" indent="0">
               <a:buNone/>
             </a:pPr>
             <a:r>
@@ -4824,7 +4665,7 @@
           <a:bodyPr wrap="square" lIns="0" tIns="0" rIns="0" bIns="0" rtlCol="0" anchor="ctr"/>
           <a:lstStyle/>
           <a:p>
-            <a:pPr indent="0" marL="0">
+            <a:pPr marL="0" indent="0">
               <a:buNone/>
             </a:pPr>
             <a:r>
@@ -4863,7 +4704,7 @@
           <a:bodyPr wrap="square" lIns="0" tIns="0" rIns="0" bIns="0" rtlCol="0" anchor="t"/>
           <a:lstStyle/>
           <a:p>
-            <a:pPr indent="0" marL="0">
+            <a:pPr marL="0" indent="0">
               <a:buNone/>
             </a:pPr>
             <a:r>
@@ -4899,7 +4740,7 @@
           <a:bodyPr wrap="square" lIns="0" tIns="0" rIns="0" bIns="0" rtlCol="0" anchor="ctr"/>
           <a:lstStyle/>
           <a:p>
-            <a:pPr indent="0" marL="0">
+            <a:pPr marL="0" indent="0">
               <a:buNone/>
             </a:pPr>
             <a:r>
@@ -4934,7 +4775,7 @@
           </a:prstGeom>
           <a:extLst>
             <a:ext uri="{C572A759-6A51-4108-AA02-DFA0A04FC94B}">
-              <ma14:wrappingTextBoxFlag xmlns:ma14="http://schemas.microsoft.com/office/mac/drawingml/2011/main" val="0"/>
+              <ma14:wrappingTextBoxFlag xmlns:ma14="http://schemas.microsoft.com/office/mac/drawingml/2011/main" xmlns="" val="0"/>
             </a:ext>
           </a:extLst>
         </p:spPr>
@@ -4952,7 +4793,7 @@
           <a:p>
             <a:pPr algn="l"/>
             <a:fld id="{F7021451-1387-4CA6-816F-3879F97B5CBC}" type="slidenum">
-              <a:rPr b="0" lang="en-US"/>
+              <a:rPr lang="en-US" b="0"/>
               <a:t>11</a:t>
             </a:fld>
             <a:endParaRPr lang="en-US"/>
@@ -4987,9 +4828,11 @@
       <p:sp>
         <p:nvSpPr>
           <p:cNvPr id="2" name="Text 0"/>
-          <p:cNvSpPr/>
+          <p:cNvSpPr>
+            <a:spLocks noGrp="1"/>
+          </p:cNvSpPr>
           <p:nvPr>
-            <p:ph idx="100" type="title" hasCustomPrompt="1"/>
+            <p:ph type="title" idx="100" hasCustomPrompt="1"/>
           </p:nvPr>
         </p:nvSpPr>
         <p:spPr>
@@ -5007,7 +4850,7 @@
           <a:bodyPr wrap="square" lIns="0" tIns="0" rIns="0" bIns="0" rtlCol="0" anchor="ctr"/>
           <a:lstStyle/>
           <a:p>
-            <a:pPr indent="0" marL="0">
+            <a:pPr marL="0" indent="0">
               <a:buNone/>
             </a:pPr>
             <a:r>
@@ -5043,7 +4886,7 @@
           <a:bodyPr wrap="square" lIns="0" tIns="0" rIns="0" bIns="0" rtlCol="0" anchor="ctr"/>
           <a:lstStyle/>
           <a:p>
-            <a:pPr indent="0" marL="0">
+            <a:pPr marL="0" indent="0">
               <a:buNone/>
             </a:pPr>
             <a:r>
@@ -5082,7 +4925,7 @@
           <a:bodyPr wrap="square" lIns="0" tIns="0" rIns="0" bIns="0" rtlCol="0" anchor="t"/>
           <a:lstStyle/>
           <a:p>
-            <a:pPr indent="0" marL="0">
+            <a:pPr marL="0" indent="0">
               <a:buNone/>
             </a:pPr>
             <a:r>
@@ -5118,7 +4961,7 @@
           <a:bodyPr wrap="square" lIns="0" tIns="0" rIns="0" bIns="0" rtlCol="0" anchor="ctr"/>
           <a:lstStyle/>
           <a:p>
-            <a:pPr indent="0" marL="0">
+            <a:pPr marL="0" indent="0">
               <a:buNone/>
             </a:pPr>
             <a:r>
@@ -5157,7 +5000,7 @@
           <a:bodyPr wrap="square" lIns="0" tIns="0" rIns="0" bIns="0" rtlCol="0" anchor="t"/>
           <a:lstStyle/>
           <a:p>
-            <a:pPr indent="0" marL="0">
+            <a:pPr marL="0" indent="0">
               <a:buNone/>
             </a:pPr>
             <a:r>
@@ -5193,7 +5036,7 @@
           <a:bodyPr wrap="square" lIns="0" tIns="0" rIns="0" bIns="0" rtlCol="0" anchor="ctr"/>
           <a:lstStyle/>
           <a:p>
-            <a:pPr indent="0" marL="0">
+            <a:pPr marL="0" indent="0">
               <a:buNone/>
             </a:pPr>
             <a:r>
@@ -5232,7 +5075,7 @@
           <a:bodyPr wrap="square" lIns="0" tIns="0" rIns="0" bIns="0" rtlCol="0" anchor="t"/>
           <a:lstStyle/>
           <a:p>
-            <a:pPr indent="0" marL="0">
+            <a:pPr marL="0" indent="0">
               <a:buNone/>
             </a:pPr>
             <a:r>
@@ -5268,7 +5111,7 @@
           <a:bodyPr wrap="square" lIns="0" tIns="0" rIns="0" bIns="0" rtlCol="0" anchor="ctr"/>
           <a:lstStyle/>
           <a:p>
-            <a:pPr indent="0" marL="0">
+            <a:pPr marL="0" indent="0">
               <a:buNone/>
             </a:pPr>
             <a:r>
@@ -5285,7 +5128,7 @@
       </p:sp>
       <p:graphicFrame>
         <p:nvGraphicFramePr>
-          <p:cNvPr id="10" name="Speed-up chart" descr=""/>
+          <p:cNvPr id="10" name="Speed-up chart"/>
           <p:cNvGraphicFramePr/>
           <p:nvPr/>
         </p:nvGraphicFramePr>
@@ -5293,9 +5136,9 @@
           <a:off x="4297680" y="1234440"/>
           <a:ext cx="7360920" cy="4023360"/>
         </p:xfrm>
-        <a:graphic xmlns:a="http://schemas.openxmlformats.org/drawingml/2006/main">
+        <a:graphic>
           <a:graphicData uri="http://schemas.openxmlformats.org/drawingml/2006/chart">
-            <c:chart xmlns:c="http://schemas.openxmlformats.org/drawingml/2006/chart" r:id="rId1"/>
+            <c:chart xmlns:c="http://schemas.openxmlformats.org/drawingml/2006/chart" xmlns:r="http://schemas.openxmlformats.org/officeDocument/2006/relationships" r:id="rId3"/>
           </a:graphicData>
         </a:graphic>
       </p:graphicFrame>
@@ -5320,7 +5163,7 @@
           <a:bodyPr wrap="square" lIns="0" tIns="0" rIns="0" bIns="0" rtlCol="0" anchor="ctr"/>
           <a:lstStyle/>
           <a:p>
-            <a:pPr indent="0" marL="0">
+            <a:pPr marL="0" indent="0">
               <a:buNone/>
             </a:pPr>
             <a:r>
@@ -5355,7 +5198,7 @@
           </a:prstGeom>
           <a:extLst>
             <a:ext uri="{C572A759-6A51-4108-AA02-DFA0A04FC94B}">
-              <ma14:wrappingTextBoxFlag xmlns:ma14="http://schemas.microsoft.com/office/mac/drawingml/2011/main" val="0"/>
+              <ma14:wrappingTextBoxFlag xmlns:ma14="http://schemas.microsoft.com/office/mac/drawingml/2011/main" xmlns="" val="0"/>
             </a:ext>
           </a:extLst>
         </p:spPr>
@@ -5373,7 +5216,7 @@
           <a:p>
             <a:pPr algn="l"/>
             <a:fld id="{F7021451-1387-4CA6-816F-3879F97B5CBC}" type="slidenum">
-              <a:rPr b="0" lang="en-US"/>
+              <a:rPr lang="en-US" b="0"/>
               <a:t>12</a:t>
             </a:fld>
             <a:endParaRPr lang="en-US"/>
@@ -5408,9 +5251,11 @@
       <p:sp>
         <p:nvSpPr>
           <p:cNvPr id="2" name="Text 0"/>
-          <p:cNvSpPr/>
+          <p:cNvSpPr>
+            <a:spLocks noGrp="1"/>
+          </p:cNvSpPr>
           <p:nvPr>
-            <p:ph idx="100" type="title" hasCustomPrompt="1"/>
+            <p:ph type="title" idx="100" hasCustomPrompt="1"/>
           </p:nvPr>
         </p:nvSpPr>
         <p:spPr>
@@ -5428,7 +5273,7 @@
           <a:bodyPr wrap="square" lIns="0" tIns="0" rIns="0" bIns="0" rtlCol="0" anchor="ctr"/>
           <a:lstStyle/>
           <a:p>
-            <a:pPr indent="0" marL="0">
+            <a:pPr marL="0" indent="0">
               <a:buNone/>
             </a:pPr>
             <a:r>
@@ -5464,7 +5309,7 @@
           <a:bodyPr wrap="square" lIns="0" tIns="0" rIns="0" bIns="0" rtlCol="0" anchor="ctr"/>
           <a:lstStyle/>
           <a:p>
-            <a:pPr indent="0" marL="0">
+            <a:pPr marL="0" indent="0">
               <a:buNone/>
             </a:pPr>
             <a:r>
@@ -5495,18 +5340,48 @@
         </p:nvGraphicFramePr>
         <p:xfrm>
           <a:off x="548640" y="1600200"/>
-          <a:ext cx="5486400" cy="914400"/>
+          <a:ext cx="5486400" cy="2048256"/>
         </p:xfrm>
         <a:graphic>
           <a:graphicData uri="http://schemas.openxmlformats.org/drawingml/2006/table">
             <a:tbl>
               <a:tblPr/>
               <a:tblGrid>
-                <a:gridCol w="1280160"/>
-                <a:gridCol w="1051560"/>
-                <a:gridCol w="1051560"/>
-                <a:gridCol w="1051560"/>
-                <a:gridCol w="1051560"/>
+                <a:gridCol w="1280160">
+                  <a:extLst>
+                    <a:ext uri="{9D8B030D-6E8A-4147-A177-3AD203B41FA5}">
+                      <a16:colId xmlns:a16="http://schemas.microsoft.com/office/drawing/2014/main" val="20000"/>
+                    </a:ext>
+                  </a:extLst>
+                </a:gridCol>
+                <a:gridCol w="1051560">
+                  <a:extLst>
+                    <a:ext uri="{9D8B030D-6E8A-4147-A177-3AD203B41FA5}">
+                      <a16:colId xmlns:a16="http://schemas.microsoft.com/office/drawing/2014/main" val="20001"/>
+                    </a:ext>
+                  </a:extLst>
+                </a:gridCol>
+                <a:gridCol w="1051560">
+                  <a:extLst>
+                    <a:ext uri="{9D8B030D-6E8A-4147-A177-3AD203B41FA5}">
+                      <a16:colId xmlns:a16="http://schemas.microsoft.com/office/drawing/2014/main" val="20002"/>
+                    </a:ext>
+                  </a:extLst>
+                </a:gridCol>
+                <a:gridCol w="1051560">
+                  <a:extLst>
+                    <a:ext uri="{9D8B030D-6E8A-4147-A177-3AD203B41FA5}">
+                      <a16:colId xmlns:a16="http://schemas.microsoft.com/office/drawing/2014/main" val="20003"/>
+                    </a:ext>
+                  </a:extLst>
+                </a:gridCol>
+                <a:gridCol w="1051560">
+                  <a:extLst>
+                    <a:ext uri="{9D8B030D-6E8A-4147-A177-3AD203B41FA5}">
+                      <a16:colId xmlns:a16="http://schemas.microsoft.com/office/drawing/2014/main" val="20004"/>
+                    </a:ext>
+                  </a:extLst>
+                </a:gridCol>
               </a:tblGrid>
               <a:tr h="0">
                 <a:tc>
@@ -5514,7 +5389,7 @@
                     <a:bodyPr/>
                     <a:lstStyle/>
                     <a:p>
-                      <a:pPr indent="0" marL="0">
+                      <a:pPr marL="0" indent="0">
                         <a:buNone/>
                       </a:pPr>
                       <a:r>
@@ -5582,7 +5457,7 @@
                     <a:bodyPr/>
                     <a:lstStyle/>
                     <a:p>
-                      <a:pPr indent="0" marL="0">
+                      <a:pPr marL="0" indent="0">
                         <a:buNone/>
                       </a:pPr>
                       <a:r>
@@ -5650,7 +5525,7 @@
                     <a:bodyPr/>
                     <a:lstStyle/>
                     <a:p>
-                      <a:pPr indent="0" marL="0">
+                      <a:pPr marL="0" indent="0">
                         <a:buNone/>
                       </a:pPr>
                       <a:r>
@@ -5718,7 +5593,7 @@
                     <a:bodyPr/>
                     <a:lstStyle/>
                     <a:p>
-                      <a:pPr indent="0" marL="0">
+                      <a:pPr marL="0" indent="0">
                         <a:buNone/>
                       </a:pPr>
                       <a:r>
@@ -5786,7 +5661,7 @@
                     <a:bodyPr/>
                     <a:lstStyle/>
                     <a:p>
-                      <a:pPr indent="0" marL="0">
+                      <a:pPr marL="0" indent="0">
                         <a:buNone/>
                       </a:pPr>
                       <a:r>
@@ -5849,6 +5724,11 @@
                     </a:solidFill>
                   </a:tcPr>
                 </a:tc>
+                <a:extLst>
+                  <a:ext uri="{0D108BD9-81ED-4DB2-BD59-A6C34878D82A}">
+                    <a16:rowId xmlns:a16="http://schemas.microsoft.com/office/drawing/2014/main" val="10000"/>
+                  </a:ext>
+                </a:extLst>
               </a:tr>
               <a:tr h="0">
                 <a:tc>
@@ -5856,7 +5736,7 @@
                     <a:bodyPr/>
                     <a:lstStyle/>
                     <a:p>
-                      <a:pPr indent="0" marL="0">
+                      <a:pPr marL="0" indent="0">
                         <a:buNone/>
                       </a:pPr>
                       <a:r>
@@ -5924,7 +5804,7 @@
                     <a:bodyPr/>
                     <a:lstStyle/>
                     <a:p>
-                      <a:pPr indent="0" marL="0">
+                      <a:pPr marL="0" indent="0">
                         <a:buNone/>
                       </a:pPr>
                       <a:r>
@@ -5992,7 +5872,7 @@
                     <a:bodyPr/>
                     <a:lstStyle/>
                     <a:p>
-                      <a:pPr indent="0" marL="0">
+                      <a:pPr marL="0" indent="0">
                         <a:buNone/>
                       </a:pPr>
                       <a:r>
@@ -6060,7 +5940,7 @@
                     <a:bodyPr/>
                     <a:lstStyle/>
                     <a:p>
-                      <a:pPr indent="0" marL="0">
+                      <a:pPr marL="0" indent="0">
                         <a:buNone/>
                       </a:pPr>
                       <a:r>
@@ -6128,7 +6008,7 @@
                     <a:bodyPr/>
                     <a:lstStyle/>
                     <a:p>
-                      <a:pPr indent="0" marL="0">
+                      <a:pPr marL="0" indent="0">
                         <a:buNone/>
                       </a:pPr>
                       <a:r>
@@ -6191,6 +6071,11 @@
                     </a:solidFill>
                   </a:tcPr>
                 </a:tc>
+                <a:extLst>
+                  <a:ext uri="{0D108BD9-81ED-4DB2-BD59-A6C34878D82A}">
+                    <a16:rowId xmlns:a16="http://schemas.microsoft.com/office/drawing/2014/main" val="10001"/>
+                  </a:ext>
+                </a:extLst>
               </a:tr>
               <a:tr h="0">
                 <a:tc>
@@ -6198,7 +6083,7 @@
                     <a:bodyPr/>
                     <a:lstStyle/>
                     <a:p>
-                      <a:pPr indent="0" marL="0">
+                      <a:pPr marL="0" indent="0">
                         <a:buNone/>
                       </a:pPr>
                       <a:r>
@@ -6266,7 +6151,7 @@
                     <a:bodyPr/>
                     <a:lstStyle/>
                     <a:p>
-                      <a:pPr indent="0" marL="0">
+                      <a:pPr marL="0" indent="0">
                         <a:buNone/>
                       </a:pPr>
                       <a:r>
@@ -6334,7 +6219,7 @@
                     <a:bodyPr/>
                     <a:lstStyle/>
                     <a:p>
-                      <a:pPr indent="0" marL="0">
+                      <a:pPr marL="0" indent="0">
                         <a:buNone/>
                       </a:pPr>
                       <a:r>
@@ -6402,7 +6287,7 @@
                     <a:bodyPr/>
                     <a:lstStyle/>
                     <a:p>
-                      <a:pPr indent="0" marL="0">
+                      <a:pPr marL="0" indent="0">
                         <a:buNone/>
                       </a:pPr>
                       <a:r>
@@ -6470,7 +6355,7 @@
                     <a:bodyPr/>
                     <a:lstStyle/>
                     <a:p>
-                      <a:pPr indent="0" marL="0">
+                      <a:pPr marL="0" indent="0">
                         <a:buNone/>
                       </a:pPr>
                       <a:r>
@@ -6533,6 +6418,11 @@
                     </a:solidFill>
                   </a:tcPr>
                 </a:tc>
+                <a:extLst>
+                  <a:ext uri="{0D108BD9-81ED-4DB2-BD59-A6C34878D82A}">
+                    <a16:rowId xmlns:a16="http://schemas.microsoft.com/office/drawing/2014/main" val="10002"/>
+                  </a:ext>
+                </a:extLst>
               </a:tr>
               <a:tr h="0">
                 <a:tc>
@@ -6540,7 +6430,7 @@
                     <a:bodyPr/>
                     <a:lstStyle/>
                     <a:p>
-                      <a:pPr indent="0" marL="0">
+                      <a:pPr marL="0" indent="0">
                         <a:buNone/>
                       </a:pPr>
                       <a:r>
@@ -6608,7 +6498,7 @@
                     <a:bodyPr/>
                     <a:lstStyle/>
                     <a:p>
-                      <a:pPr indent="0" marL="0">
+                      <a:pPr marL="0" indent="0">
                         <a:buNone/>
                       </a:pPr>
                       <a:r>
@@ -6676,7 +6566,7 @@
                     <a:bodyPr/>
                     <a:lstStyle/>
                     <a:p>
-                      <a:pPr indent="0" marL="0">
+                      <a:pPr marL="0" indent="0">
                         <a:buNone/>
                       </a:pPr>
                       <a:r>
@@ -6744,7 +6634,7 @@
                     <a:bodyPr/>
                     <a:lstStyle/>
                     <a:p>
-                      <a:pPr indent="0" marL="0">
+                      <a:pPr marL="0" indent="0">
                         <a:buNone/>
                       </a:pPr>
                       <a:r>
@@ -6812,7 +6702,7 @@
                     <a:bodyPr/>
                     <a:lstStyle/>
                     <a:p>
-                      <a:pPr indent="0" marL="0">
+                      <a:pPr marL="0" indent="0">
                         <a:buNone/>
                       </a:pPr>
                       <a:r>
@@ -6875,6 +6765,11 @@
                     </a:solidFill>
                   </a:tcPr>
                 </a:tc>
+                <a:extLst>
+                  <a:ext uri="{0D108BD9-81ED-4DB2-BD59-A6C34878D82A}">
+                    <a16:rowId xmlns:a16="http://schemas.microsoft.com/office/drawing/2014/main" val="10003"/>
+                  </a:ext>
+                </a:extLst>
               </a:tr>
               <a:tr h="0">
                 <a:tc>
@@ -6882,7 +6777,7 @@
                     <a:bodyPr/>
                     <a:lstStyle/>
                     <a:p>
-                      <a:pPr indent="0" marL="0">
+                      <a:pPr marL="0" indent="0">
                         <a:buNone/>
                       </a:pPr>
                       <a:r>
@@ -6950,7 +6845,7 @@
                     <a:bodyPr/>
                     <a:lstStyle/>
                     <a:p>
-                      <a:pPr indent="0" marL="0">
+                      <a:pPr marL="0" indent="0">
                         <a:buNone/>
                       </a:pPr>
                       <a:r>
@@ -7018,7 +6913,7 @@
                     <a:bodyPr/>
                     <a:lstStyle/>
                     <a:p>
-                      <a:pPr indent="0" marL="0">
+                      <a:pPr marL="0" indent="0">
                         <a:buNone/>
                       </a:pPr>
                       <a:r>
@@ -7086,7 +6981,7 @@
                     <a:bodyPr/>
                     <a:lstStyle/>
                     <a:p>
-                      <a:pPr indent="0" marL="0">
+                      <a:pPr marL="0" indent="0">
                         <a:buNone/>
                       </a:pPr>
                       <a:r>
@@ -7154,7 +7049,7 @@
                     <a:bodyPr/>
                     <a:lstStyle/>
                     <a:p>
-                      <a:pPr indent="0" marL="0">
+                      <a:pPr marL="0" indent="0">
                         <a:buNone/>
                       </a:pPr>
                       <a:r>
@@ -7217,6 +7112,11 @@
                     </a:solidFill>
                   </a:tcPr>
                 </a:tc>
+                <a:extLst>
+                  <a:ext uri="{0D108BD9-81ED-4DB2-BD59-A6C34878D82A}">
+                    <a16:rowId xmlns:a16="http://schemas.microsoft.com/office/drawing/2014/main" val="10004"/>
+                  </a:ext>
+                </a:extLst>
               </a:tr>
               <a:tr h="0">
                 <a:tc>
@@ -7224,7 +7124,7 @@
                     <a:bodyPr/>
                     <a:lstStyle/>
                     <a:p>
-                      <a:pPr indent="0" marL="0">
+                      <a:pPr marL="0" indent="0">
                         <a:buNone/>
                       </a:pPr>
                       <a:r>
@@ -7292,7 +7192,7 @@
                     <a:bodyPr/>
                     <a:lstStyle/>
                     <a:p>
-                      <a:pPr indent="0" marL="0">
+                      <a:pPr marL="0" indent="0">
                         <a:buNone/>
                       </a:pPr>
                       <a:r>
@@ -7360,7 +7260,7 @@
                     <a:bodyPr/>
                     <a:lstStyle/>
                     <a:p>
-                      <a:pPr indent="0" marL="0">
+                      <a:pPr marL="0" indent="0">
                         <a:buNone/>
                       </a:pPr>
                       <a:r>
@@ -7428,7 +7328,7 @@
                     <a:bodyPr/>
                     <a:lstStyle/>
                     <a:p>
-                      <a:pPr indent="0" marL="0">
+                      <a:pPr marL="0" indent="0">
                         <a:buNone/>
                       </a:pPr>
                       <a:r>
@@ -7496,7 +7396,7 @@
                     <a:bodyPr/>
                     <a:lstStyle/>
                     <a:p>
-                      <a:pPr indent="0" marL="0">
+                      <a:pPr marL="0" indent="0">
                         <a:buNone/>
                       </a:pPr>
                       <a:r>
@@ -7559,6 +7459,11 @@
                     </a:solidFill>
                   </a:tcPr>
                 </a:tc>
+                <a:extLst>
+                  <a:ext uri="{0D108BD9-81ED-4DB2-BD59-A6C34878D82A}">
+                    <a16:rowId xmlns:a16="http://schemas.microsoft.com/office/drawing/2014/main" val="10005"/>
+                  </a:ext>
+                </a:extLst>
               </a:tr>
               <a:tr h="0">
                 <a:tc>
@@ -7566,7 +7471,7 @@
                     <a:bodyPr/>
                     <a:lstStyle/>
                     <a:p>
-                      <a:pPr indent="0" marL="0">
+                      <a:pPr marL="0" indent="0">
                         <a:buNone/>
                       </a:pPr>
                       <a:r>
@@ -7634,7 +7539,7 @@
                     <a:bodyPr/>
                     <a:lstStyle/>
                     <a:p>
-                      <a:pPr indent="0" marL="0">
+                      <a:pPr marL="0" indent="0">
                         <a:buNone/>
                       </a:pPr>
                       <a:r>
@@ -7702,7 +7607,7 @@
                     <a:bodyPr/>
                     <a:lstStyle/>
                     <a:p>
-                      <a:pPr indent="0" marL="0">
+                      <a:pPr marL="0" indent="0">
                         <a:buNone/>
                       </a:pPr>
                       <a:r>
@@ -7770,7 +7675,7 @@
                     <a:bodyPr/>
                     <a:lstStyle/>
                     <a:p>
-                      <a:pPr indent="0" marL="0">
+                      <a:pPr marL="0" indent="0">
                         <a:buNone/>
                       </a:pPr>
                       <a:r>
@@ -7838,7 +7743,7 @@
                     <a:bodyPr/>
                     <a:lstStyle/>
                     <a:p>
-                      <a:pPr indent="0" marL="0">
+                      <a:pPr marL="0" indent="0">
                         <a:buNone/>
                       </a:pPr>
                       <a:r>
@@ -7901,6 +7806,11 @@
                     </a:solidFill>
                   </a:tcPr>
                 </a:tc>
+                <a:extLst>
+                  <a:ext uri="{0D108BD9-81ED-4DB2-BD59-A6C34878D82A}">
+                    <a16:rowId xmlns:a16="http://schemas.microsoft.com/office/drawing/2014/main" val="10006"/>
+                  </a:ext>
+                </a:extLst>
               </a:tr>
             </a:tbl>
           </a:graphicData>
@@ -7927,7 +7837,7 @@
           <a:bodyPr wrap="square" lIns="0" tIns="0" rIns="0" bIns="0" rtlCol="0" anchor="ctr"/>
           <a:lstStyle/>
           <a:p>
-            <a:pPr indent="0" marL="0">
+            <a:pPr marL="0" indent="0">
               <a:buNone/>
             </a:pPr>
             <a:r>
@@ -7963,7 +7873,7 @@
           <a:bodyPr wrap="square" lIns="0" tIns="0" rIns="0" bIns="0" rtlCol="0" anchor="ctr"/>
           <a:lstStyle/>
           <a:p>
-            <a:pPr indent="0" marL="0">
+            <a:pPr marL="0" indent="0">
               <a:buNone/>
             </a:pPr>
             <a:r>
@@ -7994,18 +7904,48 @@
         </p:nvGraphicFramePr>
         <p:xfrm>
           <a:off x="6355080" y="1600200"/>
-          <a:ext cx="5303520" cy="914400"/>
+          <a:ext cx="5303520" cy="1645920"/>
         </p:xfrm>
         <a:graphic>
           <a:graphicData uri="http://schemas.openxmlformats.org/drawingml/2006/table">
             <a:tbl>
               <a:tblPr/>
               <a:tblGrid>
-                <a:gridCol w="1097280"/>
-                <a:gridCol w="1005840"/>
-                <a:gridCol w="1005840"/>
-                <a:gridCol w="1097280"/>
-                <a:gridCol w="1097280"/>
+                <a:gridCol w="1097280">
+                  <a:extLst>
+                    <a:ext uri="{9D8B030D-6E8A-4147-A177-3AD203B41FA5}">
+                      <a16:colId xmlns:a16="http://schemas.microsoft.com/office/drawing/2014/main" val="20000"/>
+                    </a:ext>
+                  </a:extLst>
+                </a:gridCol>
+                <a:gridCol w="1005840">
+                  <a:extLst>
+                    <a:ext uri="{9D8B030D-6E8A-4147-A177-3AD203B41FA5}">
+                      <a16:colId xmlns:a16="http://schemas.microsoft.com/office/drawing/2014/main" val="20001"/>
+                    </a:ext>
+                  </a:extLst>
+                </a:gridCol>
+                <a:gridCol w="1005840">
+                  <a:extLst>
+                    <a:ext uri="{9D8B030D-6E8A-4147-A177-3AD203B41FA5}">
+                      <a16:colId xmlns:a16="http://schemas.microsoft.com/office/drawing/2014/main" val="20002"/>
+                    </a:ext>
+                  </a:extLst>
+                </a:gridCol>
+                <a:gridCol w="1097280">
+                  <a:extLst>
+                    <a:ext uri="{9D8B030D-6E8A-4147-A177-3AD203B41FA5}">
+                      <a16:colId xmlns:a16="http://schemas.microsoft.com/office/drawing/2014/main" val="20003"/>
+                    </a:ext>
+                  </a:extLst>
+                </a:gridCol>
+                <a:gridCol w="1097280">
+                  <a:extLst>
+                    <a:ext uri="{9D8B030D-6E8A-4147-A177-3AD203B41FA5}">
+                      <a16:colId xmlns:a16="http://schemas.microsoft.com/office/drawing/2014/main" val="20004"/>
+                    </a:ext>
+                  </a:extLst>
+                </a:gridCol>
               </a:tblGrid>
               <a:tr h="0">
                 <a:tc>
@@ -8013,7 +7953,7 @@
                     <a:bodyPr/>
                     <a:lstStyle/>
                     <a:p>
-                      <a:pPr indent="0" marL="0">
+                      <a:pPr marL="0" indent="0">
                         <a:buNone/>
                       </a:pPr>
                       <a:r>
@@ -8081,7 +8021,7 @@
                     <a:bodyPr/>
                     <a:lstStyle/>
                     <a:p>
-                      <a:pPr indent="0" marL="0">
+                      <a:pPr marL="0" indent="0">
                         <a:buNone/>
                       </a:pPr>
                       <a:r>
@@ -8149,7 +8089,7 @@
                     <a:bodyPr/>
                     <a:lstStyle/>
                     <a:p>
-                      <a:pPr indent="0" marL="0">
+                      <a:pPr marL="0" indent="0">
                         <a:buNone/>
                       </a:pPr>
                       <a:r>
@@ -8217,7 +8157,7 @@
                     <a:bodyPr/>
                     <a:lstStyle/>
                     <a:p>
-                      <a:pPr indent="0" marL="0">
+                      <a:pPr marL="0" indent="0">
                         <a:buNone/>
                       </a:pPr>
                       <a:r>
@@ -8285,7 +8225,7 @@
                     <a:bodyPr/>
                     <a:lstStyle/>
                     <a:p>
-                      <a:pPr indent="0" marL="0">
+                      <a:pPr marL="0" indent="0">
                         <a:buNone/>
                       </a:pPr>
                       <a:r>
@@ -8348,6 +8288,11 @@
                     </a:solidFill>
                   </a:tcPr>
                 </a:tc>
+                <a:extLst>
+                  <a:ext uri="{0D108BD9-81ED-4DB2-BD59-A6C34878D82A}">
+                    <a16:rowId xmlns:a16="http://schemas.microsoft.com/office/drawing/2014/main" val="10000"/>
+                  </a:ext>
+                </a:extLst>
               </a:tr>
               <a:tr h="0">
                 <a:tc>
@@ -8355,7 +8300,7 @@
                     <a:bodyPr/>
                     <a:lstStyle/>
                     <a:p>
-                      <a:pPr indent="0" marL="0">
+                      <a:pPr marL="0" indent="0">
                         <a:buNone/>
                       </a:pPr>
                       <a:r>
@@ -8423,7 +8368,7 @@
                     <a:bodyPr/>
                     <a:lstStyle/>
                     <a:p>
-                      <a:pPr indent="0" marL="0">
+                      <a:pPr marL="0" indent="0">
                         <a:buNone/>
                       </a:pPr>
                       <a:r>
@@ -8491,7 +8436,7 @@
                     <a:bodyPr/>
                     <a:lstStyle/>
                     <a:p>
-                      <a:pPr indent="0" marL="0">
+                      <a:pPr marL="0" indent="0">
                         <a:buNone/>
                       </a:pPr>
                       <a:r>
@@ -8559,7 +8504,7 @@
                     <a:bodyPr/>
                     <a:lstStyle/>
                     <a:p>
-                      <a:pPr indent="0" marL="0">
+                      <a:pPr marL="0" indent="0">
                         <a:buNone/>
                       </a:pPr>
                       <a:r>
@@ -8627,7 +8572,7 @@
                     <a:bodyPr/>
                     <a:lstStyle/>
                     <a:p>
-                      <a:pPr indent="0" marL="0">
+                      <a:pPr marL="0" indent="0">
                         <a:buNone/>
                       </a:pPr>
                       <a:r>
@@ -8690,6 +8635,11 @@
                     </a:solidFill>
                   </a:tcPr>
                 </a:tc>
+                <a:extLst>
+                  <a:ext uri="{0D108BD9-81ED-4DB2-BD59-A6C34878D82A}">
+                    <a16:rowId xmlns:a16="http://schemas.microsoft.com/office/drawing/2014/main" val="10001"/>
+                  </a:ext>
+                </a:extLst>
               </a:tr>
               <a:tr h="0">
                 <a:tc>
@@ -8697,7 +8647,7 @@
                     <a:bodyPr/>
                     <a:lstStyle/>
                     <a:p>
-                      <a:pPr indent="0" marL="0">
+                      <a:pPr marL="0" indent="0">
                         <a:buNone/>
                       </a:pPr>
                       <a:r>
@@ -8765,7 +8715,7 @@
                     <a:bodyPr/>
                     <a:lstStyle/>
                     <a:p>
-                      <a:pPr indent="0" marL="0">
+                      <a:pPr marL="0" indent="0">
                         <a:buNone/>
                       </a:pPr>
                       <a:r>
@@ -8833,7 +8783,7 @@
                     <a:bodyPr/>
                     <a:lstStyle/>
                     <a:p>
-                      <a:pPr indent="0" marL="0">
+                      <a:pPr marL="0" indent="0">
                         <a:buNone/>
                       </a:pPr>
                       <a:r>
@@ -8901,7 +8851,7 @@
                     <a:bodyPr/>
                     <a:lstStyle/>
                     <a:p>
-                      <a:pPr indent="0" marL="0">
+                      <a:pPr marL="0" indent="0">
                         <a:buNone/>
                       </a:pPr>
                       <a:r>
@@ -8969,7 +8919,7 @@
                     <a:bodyPr/>
                     <a:lstStyle/>
                     <a:p>
-                      <a:pPr indent="0" marL="0">
+                      <a:pPr marL="0" indent="0">
                         <a:buNone/>
                       </a:pPr>
                       <a:r>
@@ -9032,6 +8982,11 @@
                     </a:solidFill>
                   </a:tcPr>
                 </a:tc>
+                <a:extLst>
+                  <a:ext uri="{0D108BD9-81ED-4DB2-BD59-A6C34878D82A}">
+                    <a16:rowId xmlns:a16="http://schemas.microsoft.com/office/drawing/2014/main" val="10002"/>
+                  </a:ext>
+                </a:extLst>
               </a:tr>
               <a:tr h="0">
                 <a:tc>
@@ -9039,7 +8994,7 @@
                     <a:bodyPr/>
                     <a:lstStyle/>
                     <a:p>
-                      <a:pPr indent="0" marL="0">
+                      <a:pPr marL="0" indent="0">
                         <a:buNone/>
                       </a:pPr>
                       <a:r>
@@ -9107,7 +9062,7 @@
                     <a:bodyPr/>
                     <a:lstStyle/>
                     <a:p>
-                      <a:pPr indent="0" marL="0">
+                      <a:pPr marL="0" indent="0">
                         <a:buNone/>
                       </a:pPr>
                       <a:r>
@@ -9175,7 +9130,7 @@
                     <a:bodyPr/>
                     <a:lstStyle/>
                     <a:p>
-                      <a:pPr indent="0" marL="0">
+                      <a:pPr marL="0" indent="0">
                         <a:buNone/>
                       </a:pPr>
                       <a:r>
@@ -9243,7 +9198,7 @@
                     <a:bodyPr/>
                     <a:lstStyle/>
                     <a:p>
-                      <a:pPr indent="0" marL="0">
+                      <a:pPr marL="0" indent="0">
                         <a:buNone/>
                       </a:pPr>
                       <a:r>
@@ -9311,7 +9266,7 @@
                     <a:bodyPr/>
                     <a:lstStyle/>
                     <a:p>
-                      <a:pPr indent="0" marL="0">
+                      <a:pPr marL="0" indent="0">
                         <a:buNone/>
                       </a:pPr>
                       <a:r>
@@ -9374,6 +9329,11 @@
                     </a:solidFill>
                   </a:tcPr>
                 </a:tc>
+                <a:extLst>
+                  <a:ext uri="{0D108BD9-81ED-4DB2-BD59-A6C34878D82A}">
+                    <a16:rowId xmlns:a16="http://schemas.microsoft.com/office/drawing/2014/main" val="10003"/>
+                  </a:ext>
+                </a:extLst>
               </a:tr>
               <a:tr h="0">
                 <a:tc>
@@ -9381,7 +9341,7 @@
                     <a:bodyPr/>
                     <a:lstStyle/>
                     <a:p>
-                      <a:pPr indent="0" marL="0">
+                      <a:pPr marL="0" indent="0">
                         <a:buNone/>
                       </a:pPr>
                       <a:r>
@@ -9449,7 +9409,7 @@
                     <a:bodyPr/>
                     <a:lstStyle/>
                     <a:p>
-                      <a:pPr indent="0" marL="0">
+                      <a:pPr marL="0" indent="0">
                         <a:buNone/>
                       </a:pPr>
                       <a:r>
@@ -9517,7 +9477,7 @@
                     <a:bodyPr/>
                     <a:lstStyle/>
                     <a:p>
-                      <a:pPr indent="0" marL="0">
+                      <a:pPr marL="0" indent="0">
                         <a:buNone/>
                       </a:pPr>
                       <a:r>
@@ -9585,7 +9545,7 @@
                     <a:bodyPr/>
                     <a:lstStyle/>
                     <a:p>
-                      <a:pPr indent="0" marL="0">
+                      <a:pPr marL="0" indent="0">
                         <a:buNone/>
                       </a:pPr>
                       <a:r>
@@ -9653,7 +9613,7 @@
                     <a:bodyPr/>
                     <a:lstStyle/>
                     <a:p>
-                      <a:pPr indent="0" marL="0">
+                      <a:pPr marL="0" indent="0">
                         <a:buNone/>
                       </a:pPr>
                       <a:r>
@@ -9716,6 +9676,11 @@
                     </a:solidFill>
                   </a:tcPr>
                 </a:tc>
+                <a:extLst>
+                  <a:ext uri="{0D108BD9-81ED-4DB2-BD59-A6C34878D82A}">
+                    <a16:rowId xmlns:a16="http://schemas.microsoft.com/office/drawing/2014/main" val="10004"/>
+                  </a:ext>
+                </a:extLst>
               </a:tr>
             </a:tbl>
           </a:graphicData>
@@ -9742,7 +9707,7 @@
           <a:bodyPr wrap="square" lIns="0" tIns="0" rIns="0" bIns="0" rtlCol="0" anchor="ctr"/>
           <a:lstStyle/>
           <a:p>
-            <a:pPr indent="0" marL="0">
+            <a:pPr marL="0" indent="0">
               <a:buNone/>
             </a:pPr>
             <a:r>
@@ -9777,7 +9742,7 @@
           </a:prstGeom>
           <a:extLst>
             <a:ext uri="{C572A759-6A51-4108-AA02-DFA0A04FC94B}">
-              <ma14:wrappingTextBoxFlag xmlns:ma14="http://schemas.microsoft.com/office/mac/drawingml/2011/main" val="0"/>
+              <ma14:wrappingTextBoxFlag xmlns:ma14="http://schemas.microsoft.com/office/mac/drawingml/2011/main" xmlns="" val="0"/>
             </a:ext>
           </a:extLst>
         </p:spPr>
@@ -9795,7 +9760,7 @@
           <a:p>
             <a:pPr algn="l"/>
             <a:fld id="{F7021451-1387-4CA6-816F-3879F97B5CBC}" type="slidenum">
-              <a:rPr b="0" lang="en-US"/>
+              <a:rPr lang="en-US" b="0"/>
               <a:t>13</a:t>
             </a:fld>
             <a:endParaRPr lang="en-US"/>
@@ -9830,9 +9795,11 @@
       <p:sp>
         <p:nvSpPr>
           <p:cNvPr id="2" name="Text 0"/>
-          <p:cNvSpPr/>
+          <p:cNvSpPr>
+            <a:spLocks noGrp="1"/>
+          </p:cNvSpPr>
           <p:nvPr>
-            <p:ph idx="100" type="title" hasCustomPrompt="1"/>
+            <p:ph type="title" idx="100" hasCustomPrompt="1"/>
           </p:nvPr>
         </p:nvSpPr>
         <p:spPr>
@@ -9850,7 +9817,7 @@
           <a:bodyPr wrap="square" lIns="0" tIns="0" rIns="0" bIns="0" rtlCol="0" anchor="ctr"/>
           <a:lstStyle/>
           <a:p>
-            <a:pPr indent="0" marL="0">
+            <a:pPr marL="0" indent="0">
               <a:buNone/>
             </a:pPr>
             <a:r>
@@ -9886,7 +9853,7 @@
           <a:bodyPr wrap="square" lIns="0" tIns="0" rIns="0" bIns="0" rtlCol="0" anchor="ctr"/>
           <a:lstStyle/>
           <a:p>
-            <a:pPr indent="0" marL="0">
+            <a:pPr marL="0" indent="0">
               <a:buNone/>
             </a:pPr>
             <a:r>
@@ -9917,18 +9884,48 @@
         </p:nvGraphicFramePr>
         <p:xfrm>
           <a:off x="548640" y="1874520"/>
-          <a:ext cx="11064240" cy="914400"/>
+          <a:ext cx="11064240" cy="2261616"/>
         </p:xfrm>
         <a:graphic>
           <a:graphicData uri="http://schemas.openxmlformats.org/drawingml/2006/table">
             <a:tbl>
               <a:tblPr/>
               <a:tblGrid>
-                <a:gridCol w="2194560"/>
-                <a:gridCol w="2011680"/>
-                <a:gridCol w="2103120"/>
-                <a:gridCol w="2743200"/>
-                <a:gridCol w="2011680"/>
+                <a:gridCol w="2194560">
+                  <a:extLst>
+                    <a:ext uri="{9D8B030D-6E8A-4147-A177-3AD203B41FA5}">
+                      <a16:colId xmlns:a16="http://schemas.microsoft.com/office/drawing/2014/main" val="20000"/>
+                    </a:ext>
+                  </a:extLst>
+                </a:gridCol>
+                <a:gridCol w="2011680">
+                  <a:extLst>
+                    <a:ext uri="{9D8B030D-6E8A-4147-A177-3AD203B41FA5}">
+                      <a16:colId xmlns:a16="http://schemas.microsoft.com/office/drawing/2014/main" val="20001"/>
+                    </a:ext>
+                  </a:extLst>
+                </a:gridCol>
+                <a:gridCol w="2103120">
+                  <a:extLst>
+                    <a:ext uri="{9D8B030D-6E8A-4147-A177-3AD203B41FA5}">
+                      <a16:colId xmlns:a16="http://schemas.microsoft.com/office/drawing/2014/main" val="20002"/>
+                    </a:ext>
+                  </a:extLst>
+                </a:gridCol>
+                <a:gridCol w="2743200">
+                  <a:extLst>
+                    <a:ext uri="{9D8B030D-6E8A-4147-A177-3AD203B41FA5}">
+                      <a16:colId xmlns:a16="http://schemas.microsoft.com/office/drawing/2014/main" val="20003"/>
+                    </a:ext>
+                  </a:extLst>
+                </a:gridCol>
+                <a:gridCol w="2011680">
+                  <a:extLst>
+                    <a:ext uri="{9D8B030D-6E8A-4147-A177-3AD203B41FA5}">
+                      <a16:colId xmlns:a16="http://schemas.microsoft.com/office/drawing/2014/main" val="20004"/>
+                    </a:ext>
+                  </a:extLst>
+                </a:gridCol>
               </a:tblGrid>
               <a:tr h="0">
                 <a:tc>
@@ -9936,7 +9933,7 @@
                     <a:bodyPr/>
                     <a:lstStyle/>
                     <a:p>
-                      <a:pPr indent="0" marL="0">
+                      <a:pPr marL="0" indent="0">
                         <a:buNone/>
                       </a:pPr>
                       <a:r>
@@ -10004,7 +10001,7 @@
                     <a:bodyPr/>
                     <a:lstStyle/>
                     <a:p>
-                      <a:pPr indent="0" marL="0">
+                      <a:pPr marL="0" indent="0">
                         <a:buNone/>
                       </a:pPr>
                       <a:r>
@@ -10072,7 +10069,7 @@
                     <a:bodyPr/>
                     <a:lstStyle/>
                     <a:p>
-                      <a:pPr indent="0" marL="0">
+                      <a:pPr marL="0" indent="0">
                         <a:buNone/>
                       </a:pPr>
                       <a:r>
@@ -10140,7 +10137,7 @@
                     <a:bodyPr/>
                     <a:lstStyle/>
                     <a:p>
-                      <a:pPr indent="0" marL="0">
+                      <a:pPr marL="0" indent="0">
                         <a:buNone/>
                       </a:pPr>
                       <a:r>
@@ -10208,7 +10205,7 @@
                     <a:bodyPr/>
                     <a:lstStyle/>
                     <a:p>
-                      <a:pPr indent="0" marL="0">
+                      <a:pPr marL="0" indent="0">
                         <a:buNone/>
                       </a:pPr>
                       <a:r>
@@ -10271,6 +10268,11 @@
                     </a:solidFill>
                   </a:tcPr>
                 </a:tc>
+                <a:extLst>
+                  <a:ext uri="{0D108BD9-81ED-4DB2-BD59-A6C34878D82A}">
+                    <a16:rowId xmlns:a16="http://schemas.microsoft.com/office/drawing/2014/main" val="10000"/>
+                  </a:ext>
+                </a:extLst>
               </a:tr>
               <a:tr h="0">
                 <a:tc>
@@ -10278,7 +10280,7 @@
                     <a:bodyPr/>
                     <a:lstStyle/>
                     <a:p>
-                      <a:pPr indent="0" marL="0">
+                      <a:pPr marL="0" indent="0">
                         <a:buNone/>
                       </a:pPr>
                       <a:r>
@@ -10346,7 +10348,7 @@
                     <a:bodyPr/>
                     <a:lstStyle/>
                     <a:p>
-                      <a:pPr indent="0" marL="0">
+                      <a:pPr marL="0" indent="0">
                         <a:buNone/>
                       </a:pPr>
                       <a:r>
@@ -10414,7 +10416,7 @@
                     <a:bodyPr/>
                     <a:lstStyle/>
                     <a:p>
-                      <a:pPr indent="0" marL="0">
+                      <a:pPr marL="0" indent="0">
                         <a:buNone/>
                       </a:pPr>
                       <a:r>
@@ -10482,7 +10484,7 @@
                     <a:bodyPr/>
                     <a:lstStyle/>
                     <a:p>
-                      <a:pPr indent="0" marL="0">
+                      <a:pPr marL="0" indent="0">
                         <a:buNone/>
                       </a:pPr>
                       <a:r>
@@ -10550,7 +10552,7 @@
                     <a:bodyPr/>
                     <a:lstStyle/>
                     <a:p>
-                      <a:pPr indent="0" marL="0">
+                      <a:pPr marL="0" indent="0">
                         <a:buNone/>
                       </a:pPr>
                       <a:r>
@@ -10613,6 +10615,11 @@
                     </a:solidFill>
                   </a:tcPr>
                 </a:tc>
+                <a:extLst>
+                  <a:ext uri="{0D108BD9-81ED-4DB2-BD59-A6C34878D82A}">
+                    <a16:rowId xmlns:a16="http://schemas.microsoft.com/office/drawing/2014/main" val="10001"/>
+                  </a:ext>
+                </a:extLst>
               </a:tr>
               <a:tr h="0">
                 <a:tc>
@@ -10620,7 +10627,7 @@
                     <a:bodyPr/>
                     <a:lstStyle/>
                     <a:p>
-                      <a:pPr indent="0" marL="0">
+                      <a:pPr marL="0" indent="0">
                         <a:buNone/>
                       </a:pPr>
                       <a:r>
@@ -10688,7 +10695,7 @@
                     <a:bodyPr/>
                     <a:lstStyle/>
                     <a:p>
-                      <a:pPr indent="0" marL="0">
+                      <a:pPr marL="0" indent="0">
                         <a:buNone/>
                       </a:pPr>
                       <a:r>
@@ -10756,7 +10763,7 @@
                     <a:bodyPr/>
                     <a:lstStyle/>
                     <a:p>
-                      <a:pPr indent="0" marL="0">
+                      <a:pPr marL="0" indent="0">
                         <a:buNone/>
                       </a:pPr>
                       <a:r>
@@ -10824,7 +10831,7 @@
                     <a:bodyPr/>
                     <a:lstStyle/>
                     <a:p>
-                      <a:pPr indent="0" marL="0">
+                      <a:pPr marL="0" indent="0">
                         <a:buNone/>
                       </a:pPr>
                       <a:r>
@@ -10892,7 +10899,7 @@
                     <a:bodyPr/>
                     <a:lstStyle/>
                     <a:p>
-                      <a:pPr indent="0" marL="0">
+                      <a:pPr marL="0" indent="0">
                         <a:buNone/>
                       </a:pPr>
                       <a:r>
@@ -10955,6 +10962,11 @@
                     </a:solidFill>
                   </a:tcPr>
                 </a:tc>
+                <a:extLst>
+                  <a:ext uri="{0D108BD9-81ED-4DB2-BD59-A6C34878D82A}">
+                    <a16:rowId xmlns:a16="http://schemas.microsoft.com/office/drawing/2014/main" val="10002"/>
+                  </a:ext>
+                </a:extLst>
               </a:tr>
               <a:tr h="0">
                 <a:tc>
@@ -10962,7 +10974,7 @@
                     <a:bodyPr/>
                     <a:lstStyle/>
                     <a:p>
-                      <a:pPr indent="0" marL="0">
+                      <a:pPr marL="0" indent="0">
                         <a:buNone/>
                       </a:pPr>
                       <a:r>
@@ -11030,7 +11042,7 @@
                     <a:bodyPr/>
                     <a:lstStyle/>
                     <a:p>
-                      <a:pPr indent="0" marL="0">
+                      <a:pPr marL="0" indent="0">
                         <a:buNone/>
                       </a:pPr>
                       <a:r>
@@ -11098,7 +11110,7 @@
                     <a:bodyPr/>
                     <a:lstStyle/>
                     <a:p>
-                      <a:pPr indent="0" marL="0">
+                      <a:pPr marL="0" indent="0">
                         <a:buNone/>
                       </a:pPr>
                       <a:r>
@@ -11166,7 +11178,7 @@
                     <a:bodyPr/>
                     <a:lstStyle/>
                     <a:p>
-                      <a:pPr indent="0" marL="0">
+                      <a:pPr marL="0" indent="0">
                         <a:buNone/>
                       </a:pPr>
                       <a:r>
@@ -11234,7 +11246,7 @@
                     <a:bodyPr/>
                     <a:lstStyle/>
                     <a:p>
-                      <a:pPr indent="0" marL="0">
+                      <a:pPr marL="0" indent="0">
                         <a:buNone/>
                       </a:pPr>
                       <a:r>
@@ -11297,6 +11309,11 @@
                     </a:solidFill>
                   </a:tcPr>
                 </a:tc>
+                <a:extLst>
+                  <a:ext uri="{0D108BD9-81ED-4DB2-BD59-A6C34878D82A}">
+                    <a16:rowId xmlns:a16="http://schemas.microsoft.com/office/drawing/2014/main" val="10003"/>
+                  </a:ext>
+                </a:extLst>
               </a:tr>
               <a:tr h="0">
                 <a:tc>
@@ -11304,7 +11321,7 @@
                     <a:bodyPr/>
                     <a:lstStyle/>
                     <a:p>
-                      <a:pPr indent="0" marL="0">
+                      <a:pPr marL="0" indent="0">
                         <a:buNone/>
                       </a:pPr>
                       <a:r>
@@ -11372,7 +11389,7 @@
                     <a:bodyPr/>
                     <a:lstStyle/>
                     <a:p>
-                      <a:pPr indent="0" marL="0">
+                      <a:pPr marL="0" indent="0">
                         <a:buNone/>
                       </a:pPr>
                       <a:r>
@@ -11440,7 +11457,7 @@
                     <a:bodyPr/>
                     <a:lstStyle/>
                     <a:p>
-                      <a:pPr indent="0" marL="0">
+                      <a:pPr marL="0" indent="0">
                         <a:buNone/>
                       </a:pPr>
                       <a:r>
@@ -11508,7 +11525,7 @@
                     <a:bodyPr/>
                     <a:lstStyle/>
                     <a:p>
-                      <a:pPr indent="0" marL="0">
+                      <a:pPr marL="0" indent="0">
                         <a:buNone/>
                       </a:pPr>
                       <a:r>
@@ -11576,7 +11593,7 @@
                     <a:bodyPr/>
                     <a:lstStyle/>
                     <a:p>
-                      <a:pPr indent="0" marL="0">
+                      <a:pPr marL="0" indent="0">
                         <a:buNone/>
                       </a:pPr>
                       <a:r>
@@ -11639,6 +11656,11 @@
                     </a:solidFill>
                   </a:tcPr>
                 </a:tc>
+                <a:extLst>
+                  <a:ext uri="{0D108BD9-81ED-4DB2-BD59-A6C34878D82A}">
+                    <a16:rowId xmlns:a16="http://schemas.microsoft.com/office/drawing/2014/main" val="10004"/>
+                  </a:ext>
+                </a:extLst>
               </a:tr>
               <a:tr h="0">
                 <a:tc>
@@ -11646,7 +11668,7 @@
                     <a:bodyPr/>
                     <a:lstStyle/>
                     <a:p>
-                      <a:pPr indent="0" marL="0">
+                      <a:pPr marL="0" indent="0">
                         <a:buNone/>
                       </a:pPr>
                       <a:r>
@@ -11714,7 +11736,7 @@
                     <a:bodyPr/>
                     <a:lstStyle/>
                     <a:p>
-                      <a:pPr indent="0" marL="0">
+                      <a:pPr marL="0" indent="0">
                         <a:buNone/>
                       </a:pPr>
                       <a:r>
@@ -11782,7 +11804,7 @@
                     <a:bodyPr/>
                     <a:lstStyle/>
                     <a:p>
-                      <a:pPr indent="0" marL="0">
+                      <a:pPr marL="0" indent="0">
                         <a:buNone/>
                       </a:pPr>
                       <a:r>
@@ -11850,7 +11872,7 @@
                     <a:bodyPr/>
                     <a:lstStyle/>
                     <a:p>
-                      <a:pPr indent="0" marL="0">
+                      <a:pPr marL="0" indent="0">
                         <a:buNone/>
                       </a:pPr>
                       <a:r>
@@ -11918,7 +11940,7 @@
                     <a:bodyPr/>
                     <a:lstStyle/>
                     <a:p>
-                      <a:pPr indent="0" marL="0">
+                      <a:pPr marL="0" indent="0">
                         <a:buNone/>
                       </a:pPr>
                       <a:r>
@@ -11981,6 +12003,11 @@
                     </a:solidFill>
                   </a:tcPr>
                 </a:tc>
+                <a:extLst>
+                  <a:ext uri="{0D108BD9-81ED-4DB2-BD59-A6C34878D82A}">
+                    <a16:rowId xmlns:a16="http://schemas.microsoft.com/office/drawing/2014/main" val="10005"/>
+                  </a:ext>
+                </a:extLst>
               </a:tr>
               <a:tr h="0">
                 <a:tc>
@@ -11988,7 +12015,7 @@
                     <a:bodyPr/>
                     <a:lstStyle/>
                     <a:p>
-                      <a:pPr indent="0" marL="0">
+                      <a:pPr marL="0" indent="0">
                         <a:buNone/>
                       </a:pPr>
                       <a:r>
@@ -12056,7 +12083,7 @@
                     <a:bodyPr/>
                     <a:lstStyle/>
                     <a:p>
-                      <a:pPr indent="0" marL="0">
+                      <a:pPr marL="0" indent="0">
                         <a:buNone/>
                       </a:pPr>
                       <a:r>
@@ -12124,7 +12151,7 @@
                     <a:bodyPr/>
                     <a:lstStyle/>
                     <a:p>
-                      <a:pPr indent="0" marL="0">
+                      <a:pPr marL="0" indent="0">
                         <a:buNone/>
                       </a:pPr>
                       <a:r>
@@ -12192,7 +12219,7 @@
                     <a:bodyPr/>
                     <a:lstStyle/>
                     <a:p>
-                      <a:pPr indent="0" marL="0">
+                      <a:pPr marL="0" indent="0">
                         <a:buNone/>
                       </a:pPr>
                       <a:r>
@@ -12260,7 +12287,7 @@
                     <a:bodyPr/>
                     <a:lstStyle/>
                     <a:p>
-                      <a:pPr indent="0" marL="0">
+                      <a:pPr marL="0" indent="0">
                         <a:buNone/>
                       </a:pPr>
                       <a:r>
@@ -12323,6 +12350,11 @@
                     </a:solidFill>
                   </a:tcPr>
                 </a:tc>
+                <a:extLst>
+                  <a:ext uri="{0D108BD9-81ED-4DB2-BD59-A6C34878D82A}">
+                    <a16:rowId xmlns:a16="http://schemas.microsoft.com/office/drawing/2014/main" val="10006"/>
+                  </a:ext>
+                </a:extLst>
               </a:tr>
             </a:tbl>
           </a:graphicData>
@@ -12424,7 +12456,7 @@
           </a:prstGeom>
           <a:extLst>
             <a:ext uri="{C572A759-6A51-4108-AA02-DFA0A04FC94B}">
-              <ma14:wrappingTextBoxFlag xmlns:ma14="http://schemas.microsoft.com/office/mac/drawingml/2011/main" val="0"/>
+              <ma14:wrappingTextBoxFlag xmlns:ma14="http://schemas.microsoft.com/office/mac/drawingml/2011/main" xmlns="" val="0"/>
             </a:ext>
           </a:extLst>
         </p:spPr>
@@ -12442,7 +12474,7 @@
           <a:p>
             <a:pPr algn="l"/>
             <a:fld id="{F7021451-1387-4CA6-816F-3879F97B5CBC}" type="slidenum">
-              <a:rPr b="0" lang="en-US"/>
+              <a:rPr lang="en-US" b="0"/>
               <a:t>14</a:t>
             </a:fld>
             <a:endParaRPr lang="en-US"/>
@@ -12477,9 +12509,11 @@
       <p:sp>
         <p:nvSpPr>
           <p:cNvPr id="2" name="Text 0"/>
-          <p:cNvSpPr/>
+          <p:cNvSpPr>
+            <a:spLocks noGrp="1"/>
+          </p:cNvSpPr>
           <p:nvPr>
-            <p:ph idx="100" type="title" hasCustomPrompt="1"/>
+            <p:ph type="title" idx="100" hasCustomPrompt="1"/>
           </p:nvPr>
         </p:nvSpPr>
         <p:spPr>
@@ -12497,7 +12531,7 @@
           <a:bodyPr wrap="square" lIns="0" tIns="0" rIns="0" bIns="0" rtlCol="0" anchor="ctr"/>
           <a:lstStyle/>
           <a:p>
-            <a:pPr indent="0" marL="0">
+            <a:pPr marL="0" indent="0">
               <a:buNone/>
             </a:pPr>
             <a:r>
@@ -12560,7 +12594,7 @@
           <a:bodyPr wrap="square" lIns="0" tIns="0" rIns="0" bIns="0" rtlCol="0" anchor="t"/>
           <a:lstStyle/>
           <a:p>
-            <a:pPr indent="0" marL="0">
+            <a:pPr marL="0" indent="0">
               <a:buNone/>
             </a:pPr>
             <a:r>
@@ -12596,7 +12630,7 @@
           <a:bodyPr wrap="square" lIns="0" tIns="0" rIns="0" bIns="0" rtlCol="0" anchor="t"/>
           <a:lstStyle/>
           <a:p>
-            <a:pPr indent="0" marL="0">
+            <a:pPr marL="0" indent="0">
               <a:buNone/>
             </a:pPr>
             <a:r>
@@ -12610,7 +12644,7 @@
             <a:endParaRPr lang="en-US" sz="1600" dirty="0"/>
           </a:p>
           <a:p>
-            <a:pPr indent="0" marL="0">
+            <a:pPr marL="0" indent="0">
               <a:buNone/>
             </a:pPr>
             <a:r>
@@ -12624,7 +12658,7 @@
             <a:endParaRPr lang="en-US" sz="1600" dirty="0"/>
           </a:p>
           <a:p>
-            <a:pPr indent="0" marL="0">
+            <a:pPr marL="0" indent="0">
               <a:buNone/>
             </a:pPr>
             <a:r>
@@ -12638,7 +12672,7 @@
             <a:endParaRPr lang="en-US" sz="1600" dirty="0"/>
           </a:p>
           <a:p>
-            <a:pPr indent="0" marL="0">
+            <a:pPr marL="0" indent="0">
               <a:buNone/>
             </a:pPr>
             <a:r>
@@ -12652,7 +12686,7 @@
             <a:endParaRPr lang="en-US" sz="1600" dirty="0"/>
           </a:p>
           <a:p>
-            <a:pPr indent="0" marL="0">
+            <a:pPr marL="0" indent="0">
               <a:buNone/>
             </a:pPr>
             <a:r>
@@ -12715,7 +12749,7 @@
           <a:bodyPr wrap="square" lIns="0" tIns="0" rIns="0" bIns="0" rtlCol="0" anchor="t"/>
           <a:lstStyle/>
           <a:p>
-            <a:pPr indent="0" marL="0">
+            <a:pPr marL="0" indent="0">
               <a:buNone/>
             </a:pPr>
             <a:r>
@@ -12751,7 +12785,7 @@
           <a:bodyPr wrap="square" lIns="0" tIns="0" rIns="0" bIns="0" rtlCol="0" anchor="t"/>
           <a:lstStyle/>
           <a:p>
-            <a:pPr indent="0" marL="0">
+            <a:pPr marL="0" indent="0">
               <a:buNone/>
             </a:pPr>
             <a:r>
@@ -12765,49 +12799,29 @@
             <a:endParaRPr lang="en-US" sz="1600" dirty="0"/>
           </a:p>
           <a:p>
-            <a:pPr indent="0" marL="0">
+            <a:pPr marL="0" indent="0">
               <a:buNone/>
             </a:pPr>
+            <a:r>
+              <a:rPr lang="en-US" sz="1600">
+                <a:solidFill>
+                  <a:schemeClr val="tx1"/>
+                </a:solidFill>
+              </a:rPr>
+              <a:t>• </a:t>
+            </a:r>
             <a:r>
               <a:rPr lang="en-US" sz="1600" dirty="0">
                 <a:solidFill>
                   <a:schemeClr val="tx1"/>
                 </a:solidFill>
               </a:rPr>
-              <a:t>• Final figures and numbers in the paper</a:t>
+              <a:t>arXiv preprint and code release</a:t>
             </a:r>
             <a:endParaRPr lang="en-US" sz="1600" dirty="0"/>
           </a:p>
           <a:p>
-            <a:pPr indent="0" marL="0">
-              <a:buNone/>
-            </a:pPr>
-            <a:r>
-              <a:rPr lang="en-US" sz="1600" dirty="0">
-                <a:solidFill>
-                  <a:schemeClr val="tx1"/>
-                </a:solidFill>
-              </a:rPr>
-              <a:t>• Guide review, author list</a:t>
-            </a:r>
-            <a:endParaRPr lang="en-US" sz="1600" dirty="0"/>
-          </a:p>
-          <a:p>
-            <a:pPr indent="0" marL="0">
-              <a:buNone/>
-            </a:pPr>
-            <a:r>
-              <a:rPr lang="en-US" sz="1600" dirty="0">
-                <a:solidFill>
-                  <a:schemeClr val="tx1"/>
-                </a:solidFill>
-              </a:rPr>
-              <a:t>• arXiv preprint and code release</a:t>
-            </a:r>
-            <a:endParaRPr lang="en-US" sz="1600" dirty="0"/>
-          </a:p>
-          <a:p>
-            <a:pPr indent="0" marL="0">
+            <a:pPr marL="0" indent="0">
               <a:buNone/>
             </a:pPr>
             <a:r>
@@ -12842,7 +12856,7 @@
           </a:prstGeom>
           <a:extLst>
             <a:ext uri="{C572A759-6A51-4108-AA02-DFA0A04FC94B}">
-              <ma14:wrappingTextBoxFlag xmlns:ma14="http://schemas.microsoft.com/office/mac/drawingml/2011/main" val="0"/>
+              <ma14:wrappingTextBoxFlag xmlns:ma14="http://schemas.microsoft.com/office/mac/drawingml/2011/main" xmlns="" val="0"/>
             </a:ext>
           </a:extLst>
         </p:spPr>
@@ -12860,7 +12874,7 @@
           <a:p>
             <a:pPr algn="l"/>
             <a:fld id="{F7021451-1387-4CA6-816F-3879F97B5CBC}" type="slidenum">
-              <a:rPr b="0" lang="en-US"/>
+              <a:rPr lang="en-US" b="0"/>
               <a:t>15</a:t>
             </a:fld>
             <a:endParaRPr lang="en-US"/>
@@ -12895,9 +12909,11 @@
       <p:sp>
         <p:nvSpPr>
           <p:cNvPr id="2" name="Text 0"/>
-          <p:cNvSpPr/>
+          <p:cNvSpPr>
+            <a:spLocks noGrp="1"/>
+          </p:cNvSpPr>
           <p:nvPr>
-            <p:ph idx="100" type="title" hasCustomPrompt="1"/>
+            <p:ph type="title" idx="100" hasCustomPrompt="1"/>
           </p:nvPr>
         </p:nvSpPr>
         <p:spPr>
@@ -12915,7 +12931,7 @@
           <a:bodyPr wrap="square" lIns="0" tIns="0" rIns="0" bIns="0" rtlCol="0" anchor="b"/>
           <a:lstStyle/>
           <a:p>
-            <a:pPr algn="l" indent="0" marL="0">
+            <a:pPr marL="0" indent="0" algn="l">
               <a:buNone/>
             </a:pPr>
             <a:r>
@@ -12933,9 +12949,11 @@
       <p:sp>
         <p:nvSpPr>
           <p:cNvPr id="3" name="Text 0"/>
-          <p:cNvSpPr/>
+          <p:cNvSpPr>
+            <a:spLocks noGrp="1"/>
+          </p:cNvSpPr>
           <p:nvPr>
-            <p:ph idx="101" type="body" hasCustomPrompt="1"/>
+            <p:ph type="body" idx="101" hasCustomPrompt="1"/>
           </p:nvPr>
         </p:nvSpPr>
         <p:spPr>
@@ -12953,7 +12971,7 @@
           <a:bodyPr wrap="square" lIns="0" tIns="0" rIns="0" bIns="0" rtlCol="0" anchor="t"/>
           <a:lstStyle/>
           <a:p>
-            <a:pPr indent="0" marL="0">
+            <a:pPr marL="0" indent="0">
               <a:buNone/>
             </a:pPr>
             <a:r>
@@ -12967,7 +12985,7 @@
             <a:endParaRPr lang="en-US" sz="1800" dirty="0"/>
           </a:p>
           <a:p>
-            <a:pPr indent="0" marL="0">
+            <a:pPr marL="0" indent="0">
               <a:buNone/>
             </a:pPr>
             <a:r>
@@ -13010,9 +13028,11 @@
       <p:sp>
         <p:nvSpPr>
           <p:cNvPr id="2" name="Text 0"/>
-          <p:cNvSpPr/>
+          <p:cNvSpPr>
+            <a:spLocks noGrp="1"/>
+          </p:cNvSpPr>
           <p:nvPr>
-            <p:ph idx="100" type="title" hasCustomPrompt="1"/>
+            <p:ph type="title" idx="100" hasCustomPrompt="1"/>
           </p:nvPr>
         </p:nvSpPr>
         <p:spPr>
@@ -13030,7 +13050,7 @@
           <a:bodyPr wrap="square" lIns="0" tIns="0" rIns="0" bIns="0" rtlCol="0" anchor="ctr"/>
           <a:lstStyle/>
           <a:p>
-            <a:pPr indent="0" marL="0">
+            <a:pPr marL="0" indent="0">
               <a:buNone/>
             </a:pPr>
             <a:r>
@@ -13066,7 +13086,7 @@
           <a:bodyPr wrap="square" lIns="0" tIns="0" rIns="0" bIns="0" rtlCol="0" anchor="t"/>
           <a:lstStyle/>
           <a:p>
-            <a:pPr indent="0" marL="0">
+            <a:pPr marL="0" indent="0">
               <a:buNone/>
             </a:pPr>
             <a:r>
@@ -13077,12 +13097,6 @@
               </a:rPr>
               <a:t>Vector search. </a:t>
             </a:r>
-            <a:pPr indent="0" marL="0">
-              <a:spcAft>
-                <a:spcPts val="1000"/>
-              </a:spcAft>
-              <a:buNone/>
-            </a:pPr>
             <a:r>
               <a:rPr lang="en-US" sz="1500" dirty="0">
                 <a:solidFill>
@@ -13094,7 +13108,7 @@
             <a:endParaRPr lang="en-US" sz="1500" dirty="0"/>
           </a:p>
           <a:p>
-            <a:pPr indent="0" marL="0">
+            <a:pPr marL="0" indent="0">
               <a:buNone/>
             </a:pPr>
             <a:r>
@@ -13105,12 +13119,6 @@
               </a:rPr>
               <a:t>Why it matters. </a:t>
             </a:r>
-            <a:pPr indent="0" marL="0">
-              <a:spcAft>
-                <a:spcPts val="1000"/>
-              </a:spcAft>
-              <a:buNone/>
-            </a:pPr>
             <a:r>
               <a:rPr lang="en-US" sz="1500" dirty="0">
                 <a:solidFill>
@@ -13122,7 +13130,7 @@
             <a:endParaRPr lang="en-US" sz="1500" dirty="0"/>
           </a:p>
           <a:p>
-            <a:pPr indent="0" marL="0">
+            <a:pPr marL="0" indent="0">
               <a:buNone/>
             </a:pPr>
             <a:r>
@@ -13133,12 +13141,6 @@
               </a:rPr>
               <a:t>Why an index. </a:t>
             </a:r>
-            <a:pPr indent="0" marL="0">
-              <a:spcAft>
-                <a:spcPts val="1000"/>
-              </a:spcAft>
-              <a:buNone/>
-            </a:pPr>
             <a:r>
               <a:rPr lang="en-US" sz="1500" dirty="0">
                 <a:solidFill>
@@ -13150,7 +13152,7 @@
             <a:endParaRPr lang="en-US" sz="1500" dirty="0"/>
           </a:p>
           <a:p>
-            <a:pPr indent="0" marL="0">
+            <a:pPr marL="0" indent="0">
               <a:buNone/>
             </a:pPr>
             <a:r>
@@ -13161,12 +13163,6 @@
               </a:rPr>
               <a:t>HNSW. </a:t>
             </a:r>
-            <a:pPr indent="0" marL="0">
-              <a:spcAft>
-                <a:spcPts val="1000"/>
-              </a:spcAft>
-              <a:buNone/>
-            </a:pPr>
             <a:r>
               <a:rPr lang="en-US" sz="1500" dirty="0">
                 <a:solidFill>
@@ -13178,7 +13174,7 @@
             <a:endParaRPr lang="en-US" sz="1500" dirty="0"/>
           </a:p>
           <a:p>
-            <a:pPr indent="0" marL="0">
+            <a:pPr marL="0" indent="0">
               <a:buNone/>
             </a:pPr>
             <a:r>
@@ -13189,9 +13185,6 @@
               </a:rPr>
               <a:t>ef. </a:t>
             </a:r>
-            <a:pPr indent="0" marL="0">
-              <a:buNone/>
-            </a:pPr>
             <a:r>
               <a:rPr lang="en-US" sz="1500" dirty="0">
                 <a:solidFill>
@@ -13252,7 +13245,7 @@
           <a:bodyPr wrap="square" lIns="0" tIns="0" rIns="0" bIns="0" rtlCol="0" anchor="ctr"/>
           <a:lstStyle/>
           <a:p>
-            <a:pPr indent="0" marL="0">
+            <a:pPr marL="0" indent="0">
               <a:buNone/>
             </a:pPr>
             <a:r>
@@ -13361,7 +13354,7 @@
           <a:bodyPr wrap="square" lIns="0" tIns="0" rIns="0" bIns="0" rtlCol="0" anchor="ctr"/>
           <a:lstStyle/>
           <a:p>
-            <a:pPr indent="0" marL="0">
+            <a:pPr marL="0" indent="0">
               <a:buNone/>
             </a:pPr>
             <a:r>
@@ -13539,7 +13532,7 @@
           <a:bodyPr wrap="square" lIns="0" tIns="0" rIns="0" bIns="0" rtlCol="0" anchor="ctr"/>
           <a:lstStyle/>
           <a:p>
-            <a:pPr indent="0" marL="0">
+            <a:pPr marL="0" indent="0">
               <a:buNone/>
             </a:pPr>
             <a:r>
@@ -13857,7 +13850,7 @@
           <a:bodyPr wrap="square" lIns="0" tIns="0" rIns="0" bIns="0" rtlCol="0" anchor="ctr"/>
           <a:lstStyle/>
           <a:p>
-            <a:pPr algn="ctr" indent="0" marL="0">
+            <a:pPr marL="0" indent="0" algn="ctr">
               <a:buNone/>
             </a:pPr>
             <a:r>
@@ -14563,7 +14556,7 @@
           <a:bodyPr wrap="square" lIns="0" tIns="0" rIns="0" bIns="0" rtlCol="0" anchor="ctr"/>
           <a:lstStyle/>
           <a:p>
-            <a:pPr indent="0" marL="0">
+            <a:pPr marL="0" indent="0">
               <a:buNone/>
             </a:pPr>
             <a:r>
@@ -14599,7 +14592,7 @@
           <a:bodyPr wrap="square" lIns="0" tIns="0" rIns="0" bIns="0" rtlCol="0" anchor="ctr"/>
           <a:lstStyle/>
           <a:p>
-            <a:pPr algn="ctr" indent="0" marL="0">
+            <a:pPr marL="0" indent="0" algn="ctr">
               <a:buNone/>
             </a:pPr>
             <a:r>
@@ -14616,7 +14609,7 @@
       </p:sp>
       <p:sp>
         <p:nvSpPr>
-          <p:cNvPr id="25" name="Slide Number Placeholder 0"/>
+          <p:cNvPr id="59" name="Slide Number Placeholder 0"/>
           <p:cNvSpPr>
             <a:spLocks noGrp="1"/>
           </p:cNvSpPr>
@@ -14634,7 +14627,7 @@
           </a:prstGeom>
           <a:extLst>
             <a:ext uri="{C572A759-6A51-4108-AA02-DFA0A04FC94B}">
-              <ma14:wrappingTextBoxFlag xmlns:ma14="http://schemas.microsoft.com/office/mac/drawingml/2011/main" val="0"/>
+              <ma14:wrappingTextBoxFlag xmlns:ma14="http://schemas.microsoft.com/office/mac/drawingml/2011/main" xmlns="" val="0"/>
             </a:ext>
           </a:extLst>
         </p:spPr>
@@ -14652,7 +14645,7 @@
           <a:p>
             <a:pPr algn="l"/>
             <a:fld id="{F7021451-1387-4CA6-816F-3879F97B5CBC}" type="slidenum">
-              <a:rPr b="0" lang="en-US"/>
+              <a:rPr lang="en-US" b="0"/>
               <a:t>2</a:t>
             </a:fld>
             <a:endParaRPr lang="en-US"/>
@@ -14687,9 +14680,11 @@
       <p:sp>
         <p:nvSpPr>
           <p:cNvPr id="2" name="Text 0"/>
-          <p:cNvSpPr/>
+          <p:cNvSpPr>
+            <a:spLocks noGrp="1"/>
+          </p:cNvSpPr>
           <p:nvPr>
-            <p:ph idx="100" type="title" hasCustomPrompt="1"/>
+            <p:ph type="title" idx="100" hasCustomPrompt="1"/>
           </p:nvPr>
         </p:nvSpPr>
         <p:spPr>
@@ -14707,7 +14702,7 @@
           <a:bodyPr wrap="square" lIns="0" tIns="0" rIns="0" bIns="0" rtlCol="0" anchor="ctr"/>
           <a:lstStyle/>
           <a:p>
-            <a:pPr indent="0" marL="0">
+            <a:pPr marL="0" indent="0">
               <a:buNone/>
             </a:pPr>
             <a:r>
@@ -14743,7 +14738,7 @@
           <a:bodyPr wrap="square" lIns="0" tIns="0" rIns="0" bIns="0" rtlCol="0" anchor="ctr"/>
           <a:lstStyle/>
           <a:p>
-            <a:pPr indent="0" marL="0">
+            <a:pPr marL="0" indent="0">
               <a:buNone/>
             </a:pPr>
             <a:r>
@@ -14806,7 +14801,7 @@
           <a:bodyPr wrap="square" lIns="0" tIns="0" rIns="0" bIns="0" rtlCol="0" anchor="t"/>
           <a:lstStyle/>
           <a:p>
-            <a:pPr indent="0" marL="0">
+            <a:pPr marL="0" indent="0">
               <a:buNone/>
             </a:pPr>
             <a:r>
@@ -14842,7 +14837,7 @@
           <a:bodyPr wrap="square" lIns="0" tIns="0" rIns="0" bIns="0" rtlCol="0" anchor="t"/>
           <a:lstStyle/>
           <a:p>
-            <a:pPr indent="0" marL="0">
+            <a:pPr marL="0" indent="0">
               <a:buNone/>
             </a:pPr>
             <a:r>
@@ -14856,7 +14851,7 @@
             <a:endParaRPr lang="en-US" sz="1500" dirty="0"/>
           </a:p>
           <a:p>
-            <a:pPr indent="0" marL="0">
+            <a:pPr marL="0" indent="0">
               <a:buNone/>
             </a:pPr>
             <a:r>
@@ -14870,7 +14865,7 @@
             <a:endParaRPr lang="en-US" sz="1500" dirty="0"/>
           </a:p>
           <a:p>
-            <a:pPr indent="0" marL="0">
+            <a:pPr marL="0" indent="0">
               <a:buNone/>
             </a:pPr>
             <a:r>
@@ -14933,7 +14928,7 @@
           <a:bodyPr wrap="square" lIns="0" tIns="0" rIns="0" bIns="0" rtlCol="0" anchor="t"/>
           <a:lstStyle/>
           <a:p>
-            <a:pPr indent="0" marL="0">
+            <a:pPr marL="0" indent="0">
               <a:buNone/>
             </a:pPr>
             <a:r>
@@ -14969,7 +14964,7 @@
           <a:bodyPr wrap="square" lIns="0" tIns="0" rIns="0" bIns="0" rtlCol="0" anchor="t"/>
           <a:lstStyle/>
           <a:p>
-            <a:pPr indent="0" marL="0">
+            <a:pPr marL="0" indent="0">
               <a:buNone/>
             </a:pPr>
             <a:r>
@@ -14983,7 +14978,7 @@
             <a:endParaRPr lang="en-US" sz="1500" dirty="0"/>
           </a:p>
           <a:p>
-            <a:pPr indent="0" marL="0">
+            <a:pPr marL="0" indent="0">
               <a:buNone/>
             </a:pPr>
             <a:r>
@@ -14997,7 +14992,7 @@
             <a:endParaRPr lang="en-US" sz="1500" dirty="0"/>
           </a:p>
           <a:p>
-            <a:pPr indent="0" marL="0">
+            <a:pPr marL="0" indent="0">
               <a:buNone/>
             </a:pPr>
             <a:r>
@@ -15060,7 +15055,7 @@
           <a:bodyPr wrap="square" lIns="0" tIns="0" rIns="0" bIns="0" rtlCol="0" anchor="t"/>
           <a:lstStyle/>
           <a:p>
-            <a:pPr indent="0" marL="0">
+            <a:pPr marL="0" indent="0">
               <a:buNone/>
             </a:pPr>
             <a:r>
@@ -15096,7 +15091,7 @@
           <a:bodyPr wrap="square" lIns="0" tIns="0" rIns="0" bIns="0" rtlCol="0" anchor="t"/>
           <a:lstStyle/>
           <a:p>
-            <a:pPr indent="0" marL="0">
+            <a:pPr marL="0" indent="0">
               <a:buNone/>
             </a:pPr>
             <a:r>
@@ -15132,7 +15127,7 @@
           <a:bodyPr wrap="square" lIns="0" tIns="0" rIns="0" bIns="0" rtlCol="0" anchor="ctr"/>
           <a:lstStyle/>
           <a:p>
-            <a:pPr indent="0" marL="0">
+            <a:pPr marL="0" indent="0">
               <a:buNone/>
             </a:pPr>
             <a:r>
@@ -15167,7 +15162,7 @@
           </a:prstGeom>
           <a:extLst>
             <a:ext uri="{C572A759-6A51-4108-AA02-DFA0A04FC94B}">
-              <ma14:wrappingTextBoxFlag xmlns:ma14="http://schemas.microsoft.com/office/mac/drawingml/2011/main" val="0"/>
+              <ma14:wrappingTextBoxFlag xmlns:ma14="http://schemas.microsoft.com/office/mac/drawingml/2011/main" xmlns="" val="0"/>
             </a:ext>
           </a:extLst>
         </p:spPr>
@@ -15185,7 +15180,7 @@
           <a:p>
             <a:pPr algn="l"/>
             <a:fld id="{F7021451-1387-4CA6-816F-3879F97B5CBC}" type="slidenum">
-              <a:rPr b="0" lang="en-US"/>
+              <a:rPr lang="en-US" b="0"/>
               <a:t>3</a:t>
             </a:fld>
             <a:endParaRPr lang="en-US"/>
@@ -15220,9 +15215,11 @@
       <p:sp>
         <p:nvSpPr>
           <p:cNvPr id="2" name="Text 0"/>
-          <p:cNvSpPr/>
+          <p:cNvSpPr>
+            <a:spLocks noGrp="1"/>
+          </p:cNvSpPr>
           <p:nvPr>
-            <p:ph idx="100" type="title" hasCustomPrompt="1"/>
+            <p:ph type="title" idx="100" hasCustomPrompt="1"/>
           </p:nvPr>
         </p:nvSpPr>
         <p:spPr>
@@ -15240,7 +15237,7 @@
           <a:bodyPr wrap="square" lIns="0" tIns="0" rIns="0" bIns="0" rtlCol="0" anchor="ctr"/>
           <a:lstStyle/>
           <a:p>
-            <a:pPr indent="0" marL="0">
+            <a:pPr marL="0" indent="0">
               <a:buNone/>
             </a:pPr>
             <a:r>
@@ -15303,7 +15300,7 @@
           <a:bodyPr wrap="square" lIns="0" tIns="0" rIns="0" bIns="0" rtlCol="0" anchor="t"/>
           <a:lstStyle/>
           <a:p>
-            <a:pPr indent="0" marL="0">
+            <a:pPr marL="0" indent="0">
               <a:buNone/>
             </a:pPr>
             <a:r>
@@ -15339,7 +15336,7 @@
           <a:bodyPr wrap="square" lIns="0" tIns="0" rIns="0" bIns="0" rtlCol="0" anchor="t"/>
           <a:lstStyle/>
           <a:p>
-            <a:pPr indent="0" marL="0">
+            <a:pPr marL="0" indent="0">
               <a:buNone/>
             </a:pPr>
             <a:r>
@@ -15353,13 +15350,13 @@
             <a:endParaRPr lang="en-US" sz="1600" dirty="0"/>
           </a:p>
           <a:p>
-            <a:pPr indent="0" marL="0">
+            <a:pPr marL="0" indent="0">
               <a:buNone/>
             </a:pPr>
             <a:endParaRPr lang="en-US" sz="1600" dirty="0"/>
           </a:p>
           <a:p>
-            <a:pPr indent="0" marL="0">
+            <a:pPr marL="0" indent="0">
               <a:buNone/>
             </a:pPr>
             <a:r>
@@ -15373,7 +15370,7 @@
             <a:endParaRPr lang="en-US" sz="1600" dirty="0"/>
           </a:p>
           <a:p>
-            <a:pPr indent="0" marL="0">
+            <a:pPr marL="0" indent="0">
               <a:buNone/>
             </a:pPr>
             <a:r>
@@ -15387,7 +15384,7 @@
             <a:endParaRPr lang="en-US" sz="1600" dirty="0"/>
           </a:p>
           <a:p>
-            <a:pPr indent="0" marL="0">
+            <a:pPr marL="0" indent="0">
               <a:buNone/>
             </a:pPr>
             <a:r>
@@ -15450,7 +15447,7 @@
           <a:bodyPr wrap="square" lIns="0" tIns="0" rIns="0" bIns="0" rtlCol="0" anchor="t"/>
           <a:lstStyle/>
           <a:p>
-            <a:pPr indent="0" marL="0">
+            <a:pPr marL="0" indent="0">
               <a:buNone/>
             </a:pPr>
             <a:r>
@@ -15486,7 +15483,7 @@
           <a:bodyPr wrap="square" lIns="0" tIns="0" rIns="0" bIns="0" rtlCol="0" anchor="t"/>
           <a:lstStyle/>
           <a:p>
-            <a:pPr indent="0" marL="0">
+            <a:pPr marL="0" indent="0">
               <a:buNone/>
             </a:pPr>
             <a:r>
@@ -15500,13 +15497,13 @@
             <a:endParaRPr lang="en-US" sz="1600" dirty="0"/>
           </a:p>
           <a:p>
-            <a:pPr indent="0" marL="0">
+            <a:pPr marL="0" indent="0">
               <a:buNone/>
             </a:pPr>
             <a:endParaRPr lang="en-US" sz="1600" dirty="0"/>
           </a:p>
           <a:p>
-            <a:pPr indent="0" marL="0">
+            <a:pPr marL="0" indent="0">
               <a:buNone/>
             </a:pPr>
             <a:r>
@@ -15520,7 +15517,7 @@
             <a:endParaRPr lang="en-US" sz="1600" dirty="0"/>
           </a:p>
           <a:p>
-            <a:pPr indent="0" marL="0">
+            <a:pPr marL="0" indent="0">
               <a:buNone/>
             </a:pPr>
             <a:r>
@@ -15534,7 +15531,7 @@
             <a:endParaRPr lang="en-US" sz="1600" dirty="0"/>
           </a:p>
           <a:p>
-            <a:pPr indent="0" marL="0">
+            <a:pPr marL="0" indent="0">
               <a:buNone/>
             </a:pPr>
             <a:r>
@@ -15570,7 +15567,7 @@
           <a:bodyPr wrap="square" lIns="0" tIns="0" rIns="0" bIns="0" rtlCol="0" anchor="ctr"/>
           <a:lstStyle/>
           <a:p>
-            <a:pPr indent="0" marL="0">
+            <a:pPr marL="0" indent="0">
               <a:buNone/>
             </a:pPr>
             <a:r>
@@ -15605,7 +15602,7 @@
           </a:prstGeom>
           <a:extLst>
             <a:ext uri="{C572A759-6A51-4108-AA02-DFA0A04FC94B}">
-              <ma14:wrappingTextBoxFlag xmlns:ma14="http://schemas.microsoft.com/office/mac/drawingml/2011/main" val="0"/>
+              <ma14:wrappingTextBoxFlag xmlns:ma14="http://schemas.microsoft.com/office/mac/drawingml/2011/main" xmlns="" val="0"/>
             </a:ext>
           </a:extLst>
         </p:spPr>
@@ -15623,7 +15620,7 @@
           <a:p>
             <a:pPr algn="l"/>
             <a:fld id="{F7021451-1387-4CA6-816F-3879F97B5CBC}" type="slidenum">
-              <a:rPr b="0" lang="en-US"/>
+              <a:rPr lang="en-US" b="0"/>
               <a:t>4</a:t>
             </a:fld>
             <a:endParaRPr lang="en-US"/>
@@ -15658,9 +15655,11 @@
       <p:sp>
         <p:nvSpPr>
           <p:cNvPr id="2" name="Text 0"/>
-          <p:cNvSpPr/>
+          <p:cNvSpPr>
+            <a:spLocks noGrp="1"/>
+          </p:cNvSpPr>
           <p:nvPr>
-            <p:ph idx="100" type="title" hasCustomPrompt="1"/>
+            <p:ph type="title" idx="100" hasCustomPrompt="1"/>
           </p:nvPr>
         </p:nvSpPr>
         <p:spPr>
@@ -15678,7 +15677,7 @@
           <a:bodyPr wrap="square" lIns="0" tIns="0" rIns="0" bIns="0" rtlCol="0" anchor="ctr"/>
           <a:lstStyle/>
           <a:p>
-            <a:pPr indent="0" marL="0">
+            <a:pPr marL="0" indent="0">
               <a:buNone/>
             </a:pPr>
             <a:r>
@@ -15722,7 +15721,7 @@
           <a:bodyPr wrap="square" lIns="50800" tIns="50800" rIns="50800" bIns="50800" rtlCol="0" anchor="ctr"/>
           <a:lstStyle/>
           <a:p>
-            <a:pPr algn="ctr" indent="0" marL="0">
+            <a:pPr marL="0" indent="0" algn="ctr">
               <a:buNone/>
             </a:pPr>
             <a:r>
@@ -15766,7 +15765,7 @@
           <a:bodyPr wrap="square" lIns="50800" tIns="50800" rIns="50800" bIns="50800" rtlCol="0" anchor="ctr"/>
           <a:lstStyle/>
           <a:p>
-            <a:pPr algn="ctr" indent="0" marL="0">
+            <a:pPr marL="0" indent="0" algn="ctr">
               <a:buNone/>
             </a:pPr>
             <a:r>
@@ -15810,7 +15809,7 @@
           <a:bodyPr wrap="square" lIns="50800" tIns="50800" rIns="50800" bIns="50800" rtlCol="0" anchor="ctr"/>
           <a:lstStyle/>
           <a:p>
-            <a:pPr algn="ctr" indent="0" marL="0">
+            <a:pPr marL="0" indent="0" algn="ctr">
               <a:buNone/>
             </a:pPr>
             <a:r>
@@ -15854,7 +15853,7 @@
           <a:bodyPr wrap="square" lIns="50800" tIns="50800" rIns="50800" bIns="50800" rtlCol="0" anchor="ctr"/>
           <a:lstStyle/>
           <a:p>
-            <a:pPr algn="ctr" indent="0" marL="0">
+            <a:pPr marL="0" indent="0" algn="ctr">
               <a:buNone/>
             </a:pPr>
             <a:r>
@@ -15898,7 +15897,7 @@
           <a:bodyPr wrap="square" lIns="50800" tIns="50800" rIns="50800" bIns="50800" rtlCol="0" anchor="ctr"/>
           <a:lstStyle/>
           <a:p>
-            <a:pPr algn="ctr" indent="0" marL="0">
+            <a:pPr marL="0" indent="0" algn="ctr">
               <a:buNone/>
             </a:pPr>
             <a:r>
@@ -16030,7 +16029,7 @@
           <a:bodyPr wrap="square" lIns="0" tIns="0" rIns="0" bIns="0" rtlCol="0" anchor="ctr"/>
           <a:lstStyle/>
           <a:p>
-            <a:pPr indent="0" marL="0">
+            <a:pPr marL="0" indent="0">
               <a:buNone/>
             </a:pPr>
             <a:r>
@@ -16093,7 +16092,7 @@
           <a:bodyPr wrap="square" lIns="0" tIns="0" rIns="0" bIns="0" rtlCol="0" anchor="t"/>
           <a:lstStyle/>
           <a:p>
-            <a:pPr indent="0" marL="0">
+            <a:pPr marL="0" indent="0">
               <a:buNone/>
             </a:pPr>
             <a:r>
@@ -16129,7 +16128,7 @@
           <a:bodyPr wrap="square" lIns="0" tIns="0" rIns="0" bIns="0" rtlCol="0" anchor="t"/>
           <a:lstStyle/>
           <a:p>
-            <a:pPr indent="0" marL="0">
+            <a:pPr marL="0" indent="0">
               <a:buNone/>
             </a:pPr>
             <a:r>
@@ -16164,7 +16163,7 @@
           </a:prstGeom>
           <a:extLst>
             <a:ext uri="{C572A759-6A51-4108-AA02-DFA0A04FC94B}">
-              <ma14:wrappingTextBoxFlag xmlns:ma14="http://schemas.microsoft.com/office/mac/drawingml/2011/main" val="0"/>
+              <ma14:wrappingTextBoxFlag xmlns:ma14="http://schemas.microsoft.com/office/mac/drawingml/2011/main" xmlns="" val="0"/>
             </a:ext>
           </a:extLst>
         </p:spPr>
@@ -16182,7 +16181,7 @@
           <a:p>
             <a:pPr algn="l"/>
             <a:fld id="{F7021451-1387-4CA6-816F-3879F97B5CBC}" type="slidenum">
-              <a:rPr b="0" lang="en-US"/>
+              <a:rPr lang="en-US" b="0"/>
               <a:t>5</a:t>
             </a:fld>
             <a:endParaRPr lang="en-US"/>
@@ -16217,9 +16216,11 @@
       <p:sp>
         <p:nvSpPr>
           <p:cNvPr id="2" name="Text 0"/>
-          <p:cNvSpPr/>
+          <p:cNvSpPr>
+            <a:spLocks noGrp="1"/>
+          </p:cNvSpPr>
           <p:nvPr>
-            <p:ph idx="100" type="title" hasCustomPrompt="1"/>
+            <p:ph type="title" idx="100" hasCustomPrompt="1"/>
           </p:nvPr>
         </p:nvSpPr>
         <p:spPr>
@@ -16237,7 +16238,7 @@
           <a:bodyPr wrap="square" lIns="0" tIns="0" rIns="0" bIns="0" rtlCol="0" anchor="ctr"/>
           <a:lstStyle/>
           <a:p>
-            <a:pPr indent="0" marL="0">
+            <a:pPr marL="0" indent="0">
               <a:buNone/>
             </a:pPr>
             <a:r>
@@ -16254,14 +16255,14 @@
       </p:sp>
       <p:pic>
         <p:nvPicPr>
-          <p:cNvPr id="3" name="KS survey figure" descr="E:\shenvipranav\projects\hybridAdaEf\server_results\paper_out_20261007_112616\fig1_ks_survey.png">    </p:cNvPr>
+          <p:cNvPr id="3" name="KS survey figure" descr="E:\shenvipranav\projects\hybridAdaEf\server_results\paper_out_20261007_112616\fig1_ks_survey.png"/>
           <p:cNvPicPr>
             <a:picLocks noChangeAspect="1"/>
           </p:cNvPicPr>
           <p:nvPr/>
         </p:nvPicPr>
         <p:blipFill>
-          <a:blip r:embed="rId1"/>
+          <a:blip r:embed="rId3"/>
           <a:stretch>
             <a:fillRect/>
           </a:stretch>
@@ -16426,7 +16427,7 @@
           </a:prstGeom>
           <a:extLst>
             <a:ext uri="{C572A759-6A51-4108-AA02-DFA0A04FC94B}">
-              <ma14:wrappingTextBoxFlag xmlns:ma14="http://schemas.microsoft.com/office/mac/drawingml/2011/main" val="0"/>
+              <ma14:wrappingTextBoxFlag xmlns:ma14="http://schemas.microsoft.com/office/mac/drawingml/2011/main" xmlns="" val="0"/>
             </a:ext>
           </a:extLst>
         </p:spPr>
@@ -16444,7 +16445,7 @@
           <a:p>
             <a:pPr algn="l"/>
             <a:fld id="{F7021451-1387-4CA6-816F-3879F97B5CBC}" type="slidenum">
-              <a:rPr b="0" lang="en-US"/>
+              <a:rPr lang="en-US" b="0"/>
               <a:t>6</a:t>
             </a:fld>
             <a:endParaRPr lang="en-US"/>
@@ -16479,9 +16480,11 @@
       <p:sp>
         <p:nvSpPr>
           <p:cNvPr id="2" name="Text 0"/>
-          <p:cNvSpPr/>
+          <p:cNvSpPr>
+            <a:spLocks noGrp="1"/>
+          </p:cNvSpPr>
           <p:nvPr>
-            <p:ph idx="100" type="title" hasCustomPrompt="1"/>
+            <p:ph type="title" idx="100" hasCustomPrompt="1"/>
           </p:nvPr>
         </p:nvSpPr>
         <p:spPr>
@@ -16499,7 +16502,7 @@
           <a:bodyPr wrap="square" lIns="0" tIns="0" rIns="0" bIns="0" rtlCol="0" anchor="ctr"/>
           <a:lstStyle/>
           <a:p>
-            <a:pPr indent="0" marL="0">
+            <a:pPr marL="0" indent="0">
               <a:buNone/>
             </a:pPr>
             <a:r>
@@ -16535,7 +16538,7 @@
           <a:bodyPr wrap="square" lIns="0" tIns="0" rIns="0" bIns="0" rtlCol="0" anchor="ctr"/>
           <a:lstStyle/>
           <a:p>
-            <a:pPr indent="0" marL="0">
+            <a:pPr marL="0" indent="0">
               <a:buNone/>
             </a:pPr>
             <a:r>
@@ -16579,7 +16582,7 @@
           <a:bodyPr wrap="square" lIns="50800" tIns="50800" rIns="50800" bIns="50800" rtlCol="0" anchor="ctr"/>
           <a:lstStyle/>
           <a:p>
-            <a:pPr algn="ctr" indent="0" marL="0">
+            <a:pPr marL="0" indent="0" algn="ctr">
               <a:buNone/>
             </a:pPr>
             <a:r>
@@ -16623,7 +16626,7 @@
           <a:bodyPr wrap="square" lIns="50800" tIns="50800" rIns="50800" bIns="50800" rtlCol="0" anchor="ctr"/>
           <a:lstStyle/>
           <a:p>
-            <a:pPr algn="ctr" indent="0" marL="0">
+            <a:pPr marL="0" indent="0" algn="ctr">
               <a:buNone/>
             </a:pPr>
             <a:r>
@@ -16667,7 +16670,7 @@
           <a:bodyPr wrap="square" lIns="50800" tIns="50800" rIns="50800" bIns="50800" rtlCol="0" anchor="ctr"/>
           <a:lstStyle/>
           <a:p>
-            <a:pPr algn="ctr" indent="0" marL="0">
+            <a:pPr marL="0" indent="0" algn="ctr">
               <a:buNone/>
             </a:pPr>
             <a:r>
@@ -16751,7 +16754,7 @@
           <a:bodyPr wrap="square" lIns="0" tIns="0" rIns="0" bIns="0" rtlCol="0" anchor="ctr"/>
           <a:lstStyle/>
           <a:p>
-            <a:pPr indent="0" marL="0">
+            <a:pPr marL="0" indent="0">
               <a:buNone/>
             </a:pPr>
             <a:r>
@@ -16795,7 +16798,7 @@
           <a:bodyPr wrap="square" lIns="50800" tIns="50800" rIns="50800" bIns="50800" rtlCol="0" anchor="ctr"/>
           <a:lstStyle/>
           <a:p>
-            <a:pPr algn="ctr" indent="0" marL="0">
+            <a:pPr marL="0" indent="0" algn="ctr">
               <a:buNone/>
             </a:pPr>
             <a:r>
@@ -16839,7 +16842,7 @@
           <a:bodyPr wrap="square" lIns="50800" tIns="50800" rIns="50800" bIns="50800" rtlCol="0" anchor="ctr"/>
           <a:lstStyle/>
           <a:p>
-            <a:pPr algn="ctr" indent="0" marL="0">
+            <a:pPr marL="0" indent="0" algn="ctr">
               <a:buNone/>
             </a:pPr>
             <a:r>
@@ -16883,7 +16886,7 @@
           <a:bodyPr wrap="square" lIns="50800" tIns="50800" rIns="50800" bIns="50800" rtlCol="0" anchor="ctr"/>
           <a:lstStyle/>
           <a:p>
-            <a:pPr algn="ctr" indent="0" marL="0">
+            <a:pPr marL="0" indent="0" algn="ctr">
               <a:buNone/>
             </a:pPr>
             <a:r>
@@ -17018,7 +17021,7 @@
           <a:bodyPr wrap="square" lIns="0" tIns="0" rIns="0" bIns="0" rtlCol="0" anchor="t"/>
           <a:lstStyle/>
           <a:p>
-            <a:pPr indent="0" marL="0">
+            <a:pPr marL="0" indent="0">
               <a:buNone/>
             </a:pPr>
             <a:r>
@@ -17054,7 +17057,7 @@
           <a:bodyPr wrap="square" lIns="0" tIns="0" rIns="0" bIns="0" rtlCol="0" anchor="t"/>
           <a:lstStyle/>
           <a:p>
-            <a:pPr indent="0" marL="0">
+            <a:pPr marL="0" indent="0">
               <a:buNone/>
             </a:pPr>
             <a:r>
@@ -17165,7 +17168,7 @@
           </a:prstGeom>
           <a:extLst>
             <a:ext uri="{C572A759-6A51-4108-AA02-DFA0A04FC94B}">
-              <ma14:wrappingTextBoxFlag xmlns:ma14="http://schemas.microsoft.com/office/mac/drawingml/2011/main" val="0"/>
+              <ma14:wrappingTextBoxFlag xmlns:ma14="http://schemas.microsoft.com/office/mac/drawingml/2011/main" xmlns="" val="0"/>
             </a:ext>
           </a:extLst>
         </p:spPr>
@@ -17183,7 +17186,7 @@
           <a:p>
             <a:pPr algn="l"/>
             <a:fld id="{F7021451-1387-4CA6-816F-3879F97B5CBC}" type="slidenum">
-              <a:rPr b="0" lang="en-US"/>
+              <a:rPr lang="en-US" b="0"/>
               <a:t>7</a:t>
             </a:fld>
             <a:endParaRPr lang="en-US"/>
@@ -17218,9 +17221,11 @@
       <p:sp>
         <p:nvSpPr>
           <p:cNvPr id="2" name="Text 0"/>
-          <p:cNvSpPr/>
+          <p:cNvSpPr>
+            <a:spLocks noGrp="1"/>
+          </p:cNvSpPr>
           <p:nvPr>
-            <p:ph idx="100" type="title" hasCustomPrompt="1"/>
+            <p:ph type="title" idx="100" hasCustomPrompt="1"/>
           </p:nvPr>
         </p:nvSpPr>
         <p:spPr>
@@ -17238,7 +17243,7 @@
           <a:bodyPr wrap="square" lIns="0" tIns="0" rIns="0" bIns="0" rtlCol="0" anchor="ctr"/>
           <a:lstStyle/>
           <a:p>
-            <a:pPr indent="0" marL="0">
+            <a:pPr marL="0" indent="0">
               <a:buNone/>
             </a:pPr>
             <a:r>
@@ -17349,7 +17354,7 @@
           <a:bodyPr wrap="square" lIns="0" tIns="0" rIns="0" bIns="0" rtlCol="0" anchor="ctr"/>
           <a:lstStyle/>
           <a:p>
-            <a:pPr algn="ctr" indent="0" marL="0">
+            <a:pPr marL="0" indent="0" algn="ctr">
               <a:buNone/>
             </a:pPr>
             <a:r>
@@ -17385,7 +17390,7 @@
           <a:bodyPr wrap="square" lIns="0" tIns="0" rIns="0" bIns="0" rtlCol="0" anchor="ctr"/>
           <a:lstStyle/>
           <a:p>
-            <a:pPr algn="ctr" indent="0" marL="0">
+            <a:pPr marL="0" indent="0" algn="ctr">
               <a:buNone/>
             </a:pPr>
             <a:r>
@@ -17421,7 +17426,7 @@
           <a:bodyPr wrap="square" lIns="0" tIns="0" rIns="0" bIns="0" rtlCol="0" anchor="ctr"/>
           <a:lstStyle/>
           <a:p>
-            <a:pPr algn="ctr" indent="0" marL="0">
+            <a:pPr marL="0" indent="0" algn="ctr">
               <a:buNone/>
             </a:pPr>
             <a:r>
@@ -17457,7 +17462,7 @@
           <a:bodyPr wrap="square" lIns="0" tIns="0" rIns="0" bIns="0" rtlCol="0" anchor="ctr"/>
           <a:lstStyle/>
           <a:p>
-            <a:pPr indent="0" marL="0">
+            <a:pPr marL="0" indent="0">
               <a:buNone/>
             </a:pPr>
             <a:r>
@@ -17493,7 +17498,7 @@
           <a:bodyPr wrap="square" lIns="0" tIns="0" rIns="0" bIns="0" rtlCol="0" anchor="ctr"/>
           <a:lstStyle/>
           <a:p>
-            <a:pPr indent="0" marL="0">
+            <a:pPr marL="0" indent="0">
               <a:buNone/>
             </a:pPr>
             <a:r>
@@ -17532,7 +17537,7 @@
           <a:bodyPr wrap="square" lIns="0" tIns="0" rIns="0" bIns="0" rtlCol="0" anchor="t"/>
           <a:lstStyle/>
           <a:p>
-            <a:pPr indent="0" marL="0">
+            <a:pPr marL="0" indent="0">
               <a:buNone/>
             </a:pPr>
             <a:r>
@@ -17568,7 +17573,7 @@
           <a:bodyPr wrap="square" lIns="0" tIns="0" rIns="0" bIns="0" rtlCol="0" anchor="ctr"/>
           <a:lstStyle/>
           <a:p>
-            <a:pPr indent="0" marL="0">
+            <a:pPr marL="0" indent="0">
               <a:buNone/>
             </a:pPr>
             <a:r>
@@ -17607,7 +17612,7 @@
           <a:bodyPr wrap="square" lIns="0" tIns="0" rIns="0" bIns="0" rtlCol="0" anchor="t"/>
           <a:lstStyle/>
           <a:p>
-            <a:pPr indent="0" marL="0">
+            <a:pPr marL="0" indent="0">
               <a:buNone/>
             </a:pPr>
             <a:r>
@@ -17643,7 +17648,7 @@
           <a:bodyPr wrap="square" lIns="0" tIns="0" rIns="0" bIns="0" rtlCol="0" anchor="ctr"/>
           <a:lstStyle/>
           <a:p>
-            <a:pPr indent="0" marL="0">
+            <a:pPr marL="0" indent="0">
               <a:buNone/>
             </a:pPr>
             <a:r>
@@ -17678,7 +17683,7 @@
           </a:prstGeom>
           <a:extLst>
             <a:ext uri="{C572A759-6A51-4108-AA02-DFA0A04FC94B}">
-              <ma14:wrappingTextBoxFlag xmlns:ma14="http://schemas.microsoft.com/office/mac/drawingml/2011/main" val="0"/>
+              <ma14:wrappingTextBoxFlag xmlns:ma14="http://schemas.microsoft.com/office/mac/drawingml/2011/main" xmlns="" val="0"/>
             </a:ext>
           </a:extLst>
         </p:spPr>
@@ -17696,7 +17701,7 @@
           <a:p>
             <a:pPr algn="l"/>
             <a:fld id="{F7021451-1387-4CA6-816F-3879F97B5CBC}" type="slidenum">
-              <a:rPr b="0" lang="en-US"/>
+              <a:rPr lang="en-US" b="0"/>
               <a:t>8</a:t>
             </a:fld>
             <a:endParaRPr lang="en-US"/>
@@ -17731,9 +17736,11 @@
       <p:sp>
         <p:nvSpPr>
           <p:cNvPr id="2" name="Text 0"/>
-          <p:cNvSpPr/>
+          <p:cNvSpPr>
+            <a:spLocks noGrp="1"/>
+          </p:cNvSpPr>
           <p:nvPr>
-            <p:ph idx="100" type="title" hasCustomPrompt="1"/>
+            <p:ph type="title" idx="100" hasCustomPrompt="1"/>
           </p:nvPr>
         </p:nvSpPr>
         <p:spPr>
@@ -17751,7 +17758,7 @@
           <a:bodyPr wrap="square" lIns="0" tIns="0" rIns="0" bIns="0" rtlCol="0" anchor="ctr"/>
           <a:lstStyle/>
           <a:p>
-            <a:pPr indent="0" marL="0">
+            <a:pPr marL="0" indent="0">
               <a:buNone/>
             </a:pPr>
             <a:r>
@@ -17814,7 +17821,7 @@
           <a:bodyPr wrap="square" lIns="0" tIns="0" rIns="0" bIns="0" rtlCol="0" anchor="t"/>
           <a:lstStyle/>
           <a:p>
-            <a:pPr indent="0" marL="0">
+            <a:pPr marL="0" indent="0">
               <a:buNone/>
             </a:pPr>
             <a:r>
@@ -17850,7 +17857,7 @@
           <a:bodyPr wrap="square" lIns="0" tIns="0" rIns="0" bIns="0" rtlCol="0" anchor="t"/>
           <a:lstStyle/>
           <a:p>
-            <a:pPr indent="0" marL="0">
+            <a:pPr marL="0" indent="0">
               <a:buNone/>
             </a:pPr>
             <a:r>
@@ -17913,7 +17920,7 @@
           <a:bodyPr wrap="square" lIns="0" tIns="0" rIns="0" bIns="0" rtlCol="0" anchor="t"/>
           <a:lstStyle/>
           <a:p>
-            <a:pPr indent="0" marL="0">
+            <a:pPr marL="0" indent="0">
               <a:buNone/>
             </a:pPr>
             <a:r>
@@ -17949,7 +17956,7 @@
           <a:bodyPr wrap="square" lIns="0" tIns="0" rIns="0" bIns="0" rtlCol="0" anchor="t"/>
           <a:lstStyle/>
           <a:p>
-            <a:pPr indent="0" marL="0">
+            <a:pPr marL="0" indent="0">
               <a:buNone/>
             </a:pPr>
             <a:r>
@@ -18012,7 +18019,7 @@
           <a:bodyPr wrap="square" lIns="0" tIns="0" rIns="0" bIns="0" rtlCol="0" anchor="t"/>
           <a:lstStyle/>
           <a:p>
-            <a:pPr indent="0" marL="0">
+            <a:pPr marL="0" indent="0">
               <a:buNone/>
             </a:pPr>
             <a:r>
@@ -18048,7 +18055,7 @@
           <a:bodyPr wrap="square" lIns="0" tIns="0" rIns="0" bIns="0" rtlCol="0" anchor="t"/>
           <a:lstStyle/>
           <a:p>
-            <a:pPr indent="0" marL="0">
+            <a:pPr marL="0" indent="0">
               <a:buNone/>
             </a:pPr>
             <a:r>
@@ -18111,7 +18118,7 @@
           <a:bodyPr wrap="square" lIns="0" tIns="0" rIns="0" bIns="0" rtlCol="0" anchor="t"/>
           <a:lstStyle/>
           <a:p>
-            <a:pPr indent="0" marL="0">
+            <a:pPr marL="0" indent="0">
               <a:buNone/>
             </a:pPr>
             <a:r>
@@ -18147,7 +18154,7 @@
           <a:bodyPr wrap="square" lIns="0" tIns="0" rIns="0" bIns="0" rtlCol="0" anchor="t"/>
           <a:lstStyle/>
           <a:p>
-            <a:pPr indent="0" marL="0">
+            <a:pPr marL="0" indent="0">
               <a:buNone/>
             </a:pPr>
             <a:r>
@@ -18183,7 +18190,7 @@
           <a:bodyPr wrap="square" lIns="0" tIns="0" rIns="0" bIns="0" rtlCol="0" anchor="ctr"/>
           <a:lstStyle/>
           <a:p>
-            <a:pPr indent="0" marL="0">
+            <a:pPr marL="0" indent="0">
               <a:buNone/>
             </a:pPr>
             <a:r>
@@ -18218,7 +18225,7 @@
           </a:prstGeom>
           <a:extLst>
             <a:ext uri="{C572A759-6A51-4108-AA02-DFA0A04FC94B}">
-              <ma14:wrappingTextBoxFlag xmlns:ma14="http://schemas.microsoft.com/office/mac/drawingml/2011/main" val="0"/>
+              <ma14:wrappingTextBoxFlag xmlns:ma14="http://schemas.microsoft.com/office/mac/drawingml/2011/main" xmlns="" val="0"/>
             </a:ext>
           </a:extLst>
         </p:spPr>
@@ -18236,7 +18243,7 @@
           <a:p>
             <a:pPr algn="l"/>
             <a:fld id="{F7021451-1387-4CA6-816F-3879F97B5CBC}" type="slidenum">
-              <a:rPr b="0" lang="en-US"/>
+              <a:rPr lang="en-US" b="0"/>
               <a:t>9</a:t>
             </a:fld>
             <a:endParaRPr lang="en-US"/>
@@ -18544,4 +18551,299 @@
     </a:ext>
   </a:extLst>
 </a:theme>
+</file>
+
+<file path=ppt/theme/theme2.xml><?xml version="1.0" encoding="utf-8"?>
+<a:theme xmlns:a="http://schemas.openxmlformats.org/drawingml/2006/main" name="Office Theme">
+  <a:themeElements>
+    <a:clrScheme name="Office">
+      <a:dk1>
+        <a:sysClr val="windowText" lastClr="000000"/>
+      </a:dk1>
+      <a:lt1>
+        <a:sysClr val="window" lastClr="FFFFFF"/>
+      </a:lt1>
+      <a:dk2>
+        <a:srgbClr val="44546A"/>
+      </a:dk2>
+      <a:lt2>
+        <a:srgbClr val="E7E6E6"/>
+      </a:lt2>
+      <a:accent1>
+        <a:srgbClr val="4472C4"/>
+      </a:accent1>
+      <a:accent2>
+        <a:srgbClr val="ED7D31"/>
+      </a:accent2>
+      <a:accent3>
+        <a:srgbClr val="A5A5A5"/>
+      </a:accent3>
+      <a:accent4>
+        <a:srgbClr val="FFC000"/>
+      </a:accent4>
+      <a:accent5>
+        <a:srgbClr val="5B9BD5"/>
+      </a:accent5>
+      <a:accent6>
+        <a:srgbClr val="70AD47"/>
+      </a:accent6>
+      <a:hlink>
+        <a:srgbClr val="0563C1"/>
+      </a:hlink>
+      <a:folHlink>
+        <a:srgbClr val="954F72"/>
+      </a:folHlink>
+    </a:clrScheme>
+    <a:fontScheme name="Office">
+      <a:majorFont>
+        <a:latin typeface="Calibri Light" panose="020F0302020204030204"/>
+        <a:ea typeface=""/>
+        <a:cs typeface=""/>
+        <a:font script="Jpan" typeface="游ゴシック Light"/>
+        <a:font script="Hang" typeface="맑은 고딕"/>
+        <a:font script="Hans" typeface="等线 Light"/>
+        <a:font script="Hant" typeface="新細明體"/>
+        <a:font script="Arab" typeface="Times New Roman"/>
+        <a:font script="Hebr" typeface="Times New Roman"/>
+        <a:font script="Thai" typeface="Angsana New"/>
+        <a:font script="Ethi" typeface="Nyala"/>
+        <a:font script="Beng" typeface="Vrinda"/>
+        <a:font script="Gujr" typeface="Shruti"/>
+        <a:font script="Khmr" typeface="MoolBoran"/>
+        <a:font script="Knda" typeface="Tunga"/>
+        <a:font script="Guru" typeface="Raavi"/>
+        <a:font script="Cans" typeface="Euphemia"/>
+        <a:font script="Cher" typeface="Plantagenet Cherokee"/>
+        <a:font script="Yiii" typeface="Microsoft Yi Baiti"/>
+        <a:font script="Tibt" typeface="Microsoft Himalaya"/>
+        <a:font script="Thaa" typeface="MV Boli"/>
+        <a:font script="Deva" typeface="Mangal"/>
+        <a:font script="Telu" typeface="Gautami"/>
+        <a:font script="Taml" typeface="Latha"/>
+        <a:font script="Syrc" typeface="Estrangelo Edessa"/>
+        <a:font script="Orya" typeface="Kalinga"/>
+        <a:font script="Mlym" typeface="Kartika"/>
+        <a:font script="Laoo" typeface="DokChampa"/>
+        <a:font script="Sinh" typeface="Iskoola Pota"/>
+        <a:font script="Mong" typeface="Mongolian Baiti"/>
+        <a:font script="Viet" typeface="Times New Roman"/>
+        <a:font script="Uigh" typeface="Microsoft Uighur"/>
+        <a:font script="Geor" typeface="Sylfaen"/>
+        <a:font script="Armn" typeface="Arial"/>
+        <a:font script="Bugi" typeface="Leelawadee UI"/>
+        <a:font script="Bopo" typeface="Microsoft JhengHei"/>
+        <a:font script="Java" typeface="Javanese Text"/>
+        <a:font script="Lisu" typeface="Segoe UI"/>
+        <a:font script="Mymr" typeface="Myanmar Text"/>
+        <a:font script="Nkoo" typeface="Ebrima"/>
+        <a:font script="Olck" typeface="Nirmala UI"/>
+        <a:font script="Osma" typeface="Ebrima"/>
+        <a:font script="Phag" typeface="Phagspa"/>
+        <a:font script="Syrn" typeface="Estrangelo Edessa"/>
+        <a:font script="Syrj" typeface="Estrangelo Edessa"/>
+        <a:font script="Syre" typeface="Estrangelo Edessa"/>
+        <a:font script="Sora" typeface="Nirmala UI"/>
+        <a:font script="Tale" typeface="Microsoft Tai Le"/>
+        <a:font script="Talu" typeface="Microsoft New Tai Lue"/>
+        <a:font script="Tfng" typeface="Ebrima"/>
+      </a:majorFont>
+      <a:minorFont>
+        <a:latin typeface="Calibri" panose="020F0502020204030204"/>
+        <a:ea typeface=""/>
+        <a:cs typeface=""/>
+        <a:font script="Jpan" typeface="游ゴシック"/>
+        <a:font script="Hang" typeface="맑은 고딕"/>
+        <a:font script="Hans" typeface="等线"/>
+        <a:font script="Hant" typeface="新細明體"/>
+        <a:font script="Arab" typeface="Arial"/>
+        <a:font script="Hebr" typeface="Arial"/>
+        <a:font script="Thai" typeface="Cordia New"/>
+        <a:font script="Ethi" typeface="Nyala"/>
+        <a:font script="Beng" typeface="Vrinda"/>
+        <a:font script="Gujr" typeface="Shruti"/>
+        <a:font script="Khmr" typeface="DaunPenh"/>
+        <a:font script="Knda" typeface="Tunga"/>
+        <a:font script="Guru" typeface="Raavi"/>
+        <a:font script="Cans" typeface="Euphemia"/>
+        <a:font script="Cher" typeface="Plantagenet Cherokee"/>
+        <a:font script="Yiii" typeface="Microsoft Yi Baiti"/>
+        <a:font script="Tibt" typeface="Microsoft Himalaya"/>
+        <a:font script="Thaa" typeface="MV Boli"/>
+        <a:font script="Deva" typeface="Mangal"/>
+        <a:font script="Telu" typeface="Gautami"/>
+        <a:font script="Taml" typeface="Latha"/>
+        <a:font script="Syrc" typeface="Estrangelo Edessa"/>
+        <a:font script="Orya" typeface="Kalinga"/>
+        <a:font script="Mlym" typeface="Kartika"/>
+        <a:font script="Laoo" typeface="DokChampa"/>
+        <a:font script="Sinh" typeface="Iskoola Pota"/>
+        <a:font script="Mong" typeface="Mongolian Baiti"/>
+        <a:font script="Viet" typeface="Arial"/>
+        <a:font script="Uigh" typeface="Microsoft Uighur"/>
+        <a:font script="Geor" typeface="Sylfaen"/>
+        <a:font script="Armn" typeface="Arial"/>
+        <a:font script="Bugi" typeface="Leelawadee UI"/>
+        <a:font script="Bopo" typeface="Microsoft JhengHei"/>
+        <a:font script="Java" typeface="Javanese Text"/>
+        <a:font script="Lisu" typeface="Segoe UI"/>
+        <a:font script="Mymr" typeface="Myanmar Text"/>
+        <a:font script="Nkoo" typeface="Ebrima"/>
+        <a:font script="Olck" typeface="Nirmala UI"/>
+        <a:font script="Osma" typeface="Ebrima"/>
+        <a:font script="Phag" typeface="Phagspa"/>
+        <a:font script="Syrn" typeface="Estrangelo Edessa"/>
+        <a:font script="Syrj" typeface="Estrangelo Edessa"/>
+        <a:font script="Syre" typeface="Estrangelo Edessa"/>
+        <a:font script="Sora" typeface="Nirmala UI"/>
+        <a:font script="Tale" typeface="Microsoft Tai Le"/>
+        <a:font script="Talu" typeface="Microsoft New Tai Lue"/>
+        <a:font script="Tfng" typeface="Ebrima"/>
+      </a:minorFont>
+    </a:fontScheme>
+    <a:fmtScheme name="Office">
+      <a:fillStyleLst>
+        <a:solidFill>
+          <a:schemeClr val="phClr"/>
+        </a:solidFill>
+        <a:gradFill rotWithShape="1">
+          <a:gsLst>
+            <a:gs pos="0">
+              <a:schemeClr val="phClr">
+                <a:lumMod val="110000"/>
+                <a:satMod val="105000"/>
+                <a:tint val="67000"/>
+              </a:schemeClr>
+            </a:gs>
+            <a:gs pos="50000">
+              <a:schemeClr val="phClr">
+                <a:lumMod val="105000"/>
+                <a:satMod val="103000"/>
+                <a:tint val="73000"/>
+              </a:schemeClr>
+            </a:gs>
+            <a:gs pos="100000">
+              <a:schemeClr val="phClr">
+                <a:lumMod val="105000"/>
+                <a:satMod val="109000"/>
+                <a:tint val="81000"/>
+              </a:schemeClr>
+            </a:gs>
+          </a:gsLst>
+          <a:lin ang="5400000" scaled="0"/>
+        </a:gradFill>
+        <a:gradFill rotWithShape="1">
+          <a:gsLst>
+            <a:gs pos="0">
+              <a:schemeClr val="phClr">
+                <a:satMod val="103000"/>
+                <a:lumMod val="102000"/>
+                <a:tint val="94000"/>
+              </a:schemeClr>
+            </a:gs>
+            <a:gs pos="50000">
+              <a:schemeClr val="phClr">
+                <a:satMod val="110000"/>
+                <a:lumMod val="100000"/>
+                <a:shade val="100000"/>
+              </a:schemeClr>
+            </a:gs>
+            <a:gs pos="100000">
+              <a:schemeClr val="phClr">
+                <a:lumMod val="99000"/>
+                <a:satMod val="120000"/>
+                <a:shade val="78000"/>
+              </a:schemeClr>
+            </a:gs>
+          </a:gsLst>
+          <a:lin ang="5400000" scaled="0"/>
+        </a:gradFill>
+      </a:fillStyleLst>
+      <a:lnStyleLst>
+        <a:ln w="6350" cap="flat" cmpd="sng" algn="ctr">
+          <a:solidFill>
+            <a:schemeClr val="phClr"/>
+          </a:solidFill>
+          <a:prstDash val="solid"/>
+          <a:miter lim="800000"/>
+        </a:ln>
+        <a:ln w="12700" cap="flat" cmpd="sng" algn="ctr">
+          <a:solidFill>
+            <a:schemeClr val="phClr"/>
+          </a:solidFill>
+          <a:prstDash val="solid"/>
+          <a:miter lim="800000"/>
+        </a:ln>
+        <a:ln w="19050" cap="flat" cmpd="sng" algn="ctr">
+          <a:solidFill>
+            <a:schemeClr val="phClr"/>
+          </a:solidFill>
+          <a:prstDash val="solid"/>
+          <a:miter lim="800000"/>
+        </a:ln>
+      </a:lnStyleLst>
+      <a:effectStyleLst>
+        <a:effectStyle>
+          <a:effectLst/>
+        </a:effectStyle>
+        <a:effectStyle>
+          <a:effectLst/>
+        </a:effectStyle>
+        <a:effectStyle>
+          <a:effectLst>
+            <a:outerShdw blurRad="57150" dist="19050" dir="5400000" algn="ctr" rotWithShape="0">
+              <a:srgbClr val="000000">
+                <a:alpha val="63000"/>
+              </a:srgbClr>
+            </a:outerShdw>
+          </a:effectLst>
+        </a:effectStyle>
+      </a:effectStyleLst>
+      <a:bgFillStyleLst>
+        <a:solidFill>
+          <a:schemeClr val="phClr"/>
+        </a:solidFill>
+        <a:solidFill>
+          <a:schemeClr val="phClr">
+            <a:tint val="95000"/>
+            <a:satMod val="170000"/>
+          </a:schemeClr>
+        </a:solidFill>
+        <a:gradFill rotWithShape="1">
+          <a:gsLst>
+            <a:gs pos="0">
+              <a:schemeClr val="phClr">
+                <a:tint val="93000"/>
+                <a:satMod val="150000"/>
+                <a:shade val="98000"/>
+                <a:lumMod val="102000"/>
+              </a:schemeClr>
+            </a:gs>
+            <a:gs pos="50000">
+              <a:schemeClr val="phClr">
+                <a:tint val="98000"/>
+                <a:satMod val="130000"/>
+                <a:shade val="90000"/>
+                <a:lumMod val="103000"/>
+              </a:schemeClr>
+            </a:gs>
+            <a:gs pos="100000">
+              <a:schemeClr val="phClr">
+                <a:shade val="63000"/>
+                <a:satMod val="120000"/>
+              </a:schemeClr>
+            </a:gs>
+          </a:gsLst>
+          <a:lin ang="5400000" scaled="0"/>
+        </a:gradFill>
+      </a:bgFillStyleLst>
+    </a:fmtScheme>
+  </a:themeElements>
+  <a:objectDefaults/>
+  <a:extraClrSchemeLst/>
+  <a:extLst>
+    <a:ext uri="{05A4C25C-085E-4340-85A3-A5531E510DB2}">
+      <thm15:themeFamily xmlns:thm15="http://schemas.microsoft.com/office/thememl/2012/main" name="Office Theme" id="{62F939B6-93AF-4DB8-9C6B-D6C7DFDC589F}" vid="{4A3C46E8-61CC-4603-A589-7422A47A8E4A}"/>
+    </a:ext>
+  </a:extLst>
+</a:theme>
 </file>
</xml_diff>